<commit_message>
added AFM picture -> explanation still missing fixed methods figures
</commit_message>
<xml_diff>
--- a/correcting presenatation.pptx
+++ b/correcting presenatation.pptx
@@ -5,12 +5,16 @@
     <p:sldMasterId id="2147483648" r:id="rId1"/>
   </p:sldMasterIdLst>
   <p:notesMasterIdLst>
-    <p:notesMasterId r:id="rId5"/>
+    <p:notesMasterId r:id="rId9"/>
   </p:notesMasterIdLst>
   <p:sldIdLst>
     <p:sldId id="256" r:id="rId2"/>
     <p:sldId id="257" r:id="rId3"/>
     <p:sldId id="258" r:id="rId4"/>
+    <p:sldId id="259" r:id="rId5"/>
+    <p:sldId id="260" r:id="rId6"/>
+    <p:sldId id="261" r:id="rId7"/>
+    <p:sldId id="262" r:id="rId8"/>
   </p:sldIdLst>
   <p:sldSz cx="12192000" cy="6858000"/>
   <p:notesSz cx="6858000" cy="9144000"/>
@@ -109,6 +113,11 @@
       </a:defRPr>
     </a:lvl9pPr>
   </p:defaultTextStyle>
+  <p:extLst>
+    <p:ext uri="{EFAFB233-063F-42B5-8137-9DF3F51BA10A}">
+      <p15:sldGuideLst xmlns:p15="http://schemas.microsoft.com/office/powerpoint/2012/main"/>
+    </p:ext>
+  </p:extLst>
 </p:presentation>
 </file>
 
@@ -194,7 +203,7 @@
           <a:p>
             <a:fld id="{64A89AAA-76F1-4CA0-80AA-F05F7132AB43}" type="datetimeFigureOut">
               <a:rPr lang="en-AU" smtClean="0"/>
-              <a:t>22/08/2025</a:t>
+              <a:t>25/08/2025</a:t>
             </a:fld>
             <a:endParaRPr lang="en-AU"/>
           </a:p>
@@ -546,6 +555,90 @@
 </p:notes>
 </file>
 
+<file path=ppt/notesSlides/notesSlide2.xml><?xml version="1.0" encoding="utf-8"?>
+<p:notes xmlns:a="http://schemas.openxmlformats.org/drawingml/2006/main" xmlns:r="http://schemas.openxmlformats.org/officeDocument/2006/relationships" xmlns:p="http://schemas.openxmlformats.org/presentationml/2006/main">
+  <p:cSld>
+    <p:spTree>
+      <p:nvGrpSpPr>
+        <p:cNvPr id="1" name=""/>
+        <p:cNvGrpSpPr/>
+        <p:nvPr/>
+      </p:nvGrpSpPr>
+      <p:grpSpPr>
+        <a:xfrm>
+          <a:off x="0" y="0"/>
+          <a:ext cx="0" cy="0"/>
+          <a:chOff x="0" y="0"/>
+          <a:chExt cx="0" cy="0"/>
+        </a:xfrm>
+      </p:grpSpPr>
+      <p:sp>
+        <p:nvSpPr>
+          <p:cNvPr id="2" name="Slide Image Placeholder 1"/>
+          <p:cNvSpPr>
+            <a:spLocks noGrp="1" noRot="1" noChangeAspect="1"/>
+          </p:cNvSpPr>
+          <p:nvPr>
+            <p:ph type="sldImg"/>
+          </p:nvPr>
+        </p:nvSpPr>
+        <p:spPr/>
+      </p:sp>
+      <p:sp>
+        <p:nvSpPr>
+          <p:cNvPr id="3" name="Notes Placeholder 2"/>
+          <p:cNvSpPr>
+            <a:spLocks noGrp="1"/>
+          </p:cNvSpPr>
+          <p:nvPr>
+            <p:ph type="body" idx="1"/>
+          </p:nvPr>
+        </p:nvSpPr>
+        <p:spPr/>
+        <p:txBody>
+          <a:bodyPr/>
+          <a:lstStyle/>
+          <a:p>
+            <a:endParaRPr lang="en-AU" dirty="0"/>
+          </a:p>
+        </p:txBody>
+      </p:sp>
+      <p:sp>
+        <p:nvSpPr>
+          <p:cNvPr id="4" name="Slide Number Placeholder 3"/>
+          <p:cNvSpPr>
+            <a:spLocks noGrp="1"/>
+          </p:cNvSpPr>
+          <p:nvPr>
+            <p:ph type="sldNum" sz="quarter" idx="5"/>
+          </p:nvPr>
+        </p:nvSpPr>
+        <p:spPr/>
+        <p:txBody>
+          <a:bodyPr/>
+          <a:lstStyle/>
+          <a:p>
+            <a:fld id="{1A1012EA-23AF-47D3-B1BD-522111E0F381}" type="slidenum">
+              <a:rPr lang="en-AU" smtClean="0"/>
+              <a:t>3</a:t>
+            </a:fld>
+            <a:endParaRPr lang="en-AU"/>
+          </a:p>
+        </p:txBody>
+      </p:sp>
+    </p:spTree>
+    <p:extLst>
+      <p:ext uri="{BB962C8B-B14F-4D97-AF65-F5344CB8AC3E}">
+        <p14:creationId xmlns:p14="http://schemas.microsoft.com/office/powerpoint/2010/main" val="3871646966"/>
+      </p:ext>
+    </p:extLst>
+  </p:cSld>
+  <p:clrMapOvr>
+    <a:masterClrMapping/>
+  </p:clrMapOvr>
+</p:notes>
+</file>
+
 <file path=ppt/slideLayouts/slideLayout1.xml><?xml version="1.0" encoding="utf-8"?>
 <p:sldLayout xmlns:a="http://schemas.openxmlformats.org/drawingml/2006/main" xmlns:r="http://schemas.openxmlformats.org/officeDocument/2006/relationships" xmlns:p="http://schemas.openxmlformats.org/presentationml/2006/main" type="title" preserve="1">
   <p:cSld name="Title Slide">
@@ -695,7 +788,7 @@
           <a:p>
             <a:fld id="{09C86A1F-4A6D-428C-A8C7-676077E82A7D}" type="datetimeFigureOut">
               <a:rPr lang="en-AU" smtClean="0"/>
-              <a:t>22/08/2025</a:t>
+              <a:t>25/08/2025</a:t>
             </a:fld>
             <a:endParaRPr lang="en-AU"/>
           </a:p>
@@ -895,7 +988,7 @@
           <a:p>
             <a:fld id="{09C86A1F-4A6D-428C-A8C7-676077E82A7D}" type="datetimeFigureOut">
               <a:rPr lang="en-AU" smtClean="0"/>
-              <a:t>22/08/2025</a:t>
+              <a:t>25/08/2025</a:t>
             </a:fld>
             <a:endParaRPr lang="en-AU"/>
           </a:p>
@@ -1105,7 +1198,7 @@
           <a:p>
             <a:fld id="{09C86A1F-4A6D-428C-A8C7-676077E82A7D}" type="datetimeFigureOut">
               <a:rPr lang="en-AU" smtClean="0"/>
-              <a:t>22/08/2025</a:t>
+              <a:t>25/08/2025</a:t>
             </a:fld>
             <a:endParaRPr lang="en-AU"/>
           </a:p>
@@ -1305,7 +1398,7 @@
           <a:p>
             <a:fld id="{09C86A1F-4A6D-428C-A8C7-676077E82A7D}" type="datetimeFigureOut">
               <a:rPr lang="en-AU" smtClean="0"/>
-              <a:t>22/08/2025</a:t>
+              <a:t>25/08/2025</a:t>
             </a:fld>
             <a:endParaRPr lang="en-AU"/>
           </a:p>
@@ -1581,7 +1674,7 @@
           <a:p>
             <a:fld id="{09C86A1F-4A6D-428C-A8C7-676077E82A7D}" type="datetimeFigureOut">
               <a:rPr lang="en-AU" smtClean="0"/>
-              <a:t>22/08/2025</a:t>
+              <a:t>25/08/2025</a:t>
             </a:fld>
             <a:endParaRPr lang="en-AU"/>
           </a:p>
@@ -1849,7 +1942,7 @@
           <a:p>
             <a:fld id="{09C86A1F-4A6D-428C-A8C7-676077E82A7D}" type="datetimeFigureOut">
               <a:rPr lang="en-AU" smtClean="0"/>
-              <a:t>22/08/2025</a:t>
+              <a:t>25/08/2025</a:t>
             </a:fld>
             <a:endParaRPr lang="en-AU"/>
           </a:p>
@@ -2264,7 +2357,7 @@
           <a:p>
             <a:fld id="{09C86A1F-4A6D-428C-A8C7-676077E82A7D}" type="datetimeFigureOut">
               <a:rPr lang="en-AU" smtClean="0"/>
-              <a:t>22/08/2025</a:t>
+              <a:t>25/08/2025</a:t>
             </a:fld>
             <a:endParaRPr lang="en-AU"/>
           </a:p>
@@ -2406,7 +2499,7 @@
           <a:p>
             <a:fld id="{09C86A1F-4A6D-428C-A8C7-676077E82A7D}" type="datetimeFigureOut">
               <a:rPr lang="en-AU" smtClean="0"/>
-              <a:t>22/08/2025</a:t>
+              <a:t>25/08/2025</a:t>
             </a:fld>
             <a:endParaRPr lang="en-AU"/>
           </a:p>
@@ -2519,7 +2612,7 @@
           <a:p>
             <a:fld id="{09C86A1F-4A6D-428C-A8C7-676077E82A7D}" type="datetimeFigureOut">
               <a:rPr lang="en-AU" smtClean="0"/>
-              <a:t>22/08/2025</a:t>
+              <a:t>25/08/2025</a:t>
             </a:fld>
             <a:endParaRPr lang="en-AU"/>
           </a:p>
@@ -2832,7 +2925,7 @@
           <a:p>
             <a:fld id="{09C86A1F-4A6D-428C-A8C7-676077E82A7D}" type="datetimeFigureOut">
               <a:rPr lang="en-AU" smtClean="0"/>
-              <a:t>22/08/2025</a:t>
+              <a:t>25/08/2025</a:t>
             </a:fld>
             <a:endParaRPr lang="en-AU"/>
           </a:p>
@@ -3121,7 +3214,7 @@
           <a:p>
             <a:fld id="{09C86A1F-4A6D-428C-A8C7-676077E82A7D}" type="datetimeFigureOut">
               <a:rPr lang="en-AU" smtClean="0"/>
-              <a:t>22/08/2025</a:t>
+              <a:t>25/08/2025</a:t>
             </a:fld>
             <a:endParaRPr lang="en-AU"/>
           </a:p>
@@ -3364,7 +3457,7 @@
           <a:p>
             <a:fld id="{09C86A1F-4A6D-428C-A8C7-676077E82A7D}" type="datetimeFigureOut">
               <a:rPr lang="en-AU" smtClean="0"/>
-              <a:t>22/08/2025</a:t>
+              <a:t>25/08/2025</a:t>
             </a:fld>
             <a:endParaRPr lang="en-AU"/>
           </a:p>
@@ -5306,35 +5399,1384 @@
           </a:p>
         </p:txBody>
       </p:sp>
-      <p:sp>
-        <p:nvSpPr>
-          <p:cNvPr id="3" name="Content Placeholder 2">
-            <a:extLst>
-              <a:ext uri="{FF2B5EF4-FFF2-40B4-BE49-F238E27FC236}">
-                <a16:creationId xmlns:a16="http://schemas.microsoft.com/office/drawing/2014/main" id="{A19DB7BC-D6E0-AD91-8590-295330BE6CB8}"/>
-              </a:ext>
-            </a:extLst>
-          </p:cNvPr>
-          <p:cNvSpPr>
-            <a:spLocks noGrp="1"/>
-          </p:cNvSpPr>
+      <p:pic>
+        <p:nvPicPr>
+          <p:cNvPr id="5" name="Content Placeholder 4">
+            <a:extLst>
+              <a:ext uri="{FF2B5EF4-FFF2-40B4-BE49-F238E27FC236}">
+                <a16:creationId xmlns:a16="http://schemas.microsoft.com/office/drawing/2014/main" id="{CE797B0B-0C25-495D-5AA7-4F3957744208}"/>
+              </a:ext>
+            </a:extLst>
+          </p:cNvPr>
+          <p:cNvPicPr>
+            <a:picLocks noGrp="1" noChangeAspect="1"/>
+          </p:cNvPicPr>
           <p:nvPr>
             <p:ph idx="1"/>
           </p:nvPr>
-        </p:nvSpPr>
-        <p:spPr/>
-        <p:txBody>
-          <a:bodyPr/>
-          <a:lstStyle/>
-          <a:p>
-            <a:endParaRPr lang="en-AU"/>
-          </a:p>
-        </p:txBody>
-      </p:sp>
+        </p:nvPicPr>
+        <p:blipFill>
+          <a:blip r:embed="rId3">
+            <a:extLst>
+              <a:ext uri="{28A0092B-C50C-407E-A947-70E740481C1C}">
+                <a14:useLocalDpi xmlns:a14="http://schemas.microsoft.com/office/drawing/2010/main" val="0"/>
+              </a:ext>
+            </a:extLst>
+          </a:blip>
+          <a:srcRect l="39440" r="23661"/>
+          <a:stretch>
+            <a:fillRect/>
+          </a:stretch>
+        </p:blipFill>
+        <p:spPr>
+          <a:xfrm>
+            <a:off x="1049957" y="1117553"/>
+            <a:ext cx="10157409" cy="4199032"/>
+          </a:xfrm>
+        </p:spPr>
+      </p:pic>
+      <p:sp>
+        <p:nvSpPr>
+          <p:cNvPr id="6" name="Rectangle 5">
+            <a:extLst>
+              <a:ext uri="{FF2B5EF4-FFF2-40B4-BE49-F238E27FC236}">
+                <a16:creationId xmlns:a16="http://schemas.microsoft.com/office/drawing/2014/main" id="{41306876-EB06-5530-A153-82106BC04B1D}"/>
+              </a:ext>
+            </a:extLst>
+          </p:cNvPr>
+          <p:cNvSpPr/>
+          <p:nvPr/>
+        </p:nvSpPr>
+        <p:spPr>
+          <a:xfrm>
+            <a:off x="3714750" y="4759372"/>
+            <a:ext cx="771525" cy="352425"/>
+          </a:xfrm>
+          <a:prstGeom prst="rect">
+            <a:avLst/>
+          </a:prstGeom>
+          <a:solidFill>
+            <a:srgbClr val="FFFFFF"/>
+          </a:solidFill>
+          <a:ln>
+            <a:noFill/>
+          </a:ln>
+        </p:spPr>
+        <p:style>
+          <a:lnRef idx="2">
+            <a:schemeClr val="accent1">
+              <a:shade val="15000"/>
+            </a:schemeClr>
+          </a:lnRef>
+          <a:fillRef idx="1">
+            <a:schemeClr val="accent1"/>
+          </a:fillRef>
+          <a:effectRef idx="0">
+            <a:schemeClr val="accent1"/>
+          </a:effectRef>
+          <a:fontRef idx="minor">
+            <a:schemeClr val="lt1"/>
+          </a:fontRef>
+        </p:style>
+        <p:txBody>
+          <a:bodyPr rtlCol="0" anchor="ctr"/>
+          <a:lstStyle/>
+          <a:p>
+            <a:pPr algn="ctr"/>
+            <a:endParaRPr lang="en-AU"/>
+          </a:p>
+        </p:txBody>
+      </p:sp>
+      <p:pic>
+        <p:nvPicPr>
+          <p:cNvPr id="8" name="Picture 7">
+            <a:extLst>
+              <a:ext uri="{FF2B5EF4-FFF2-40B4-BE49-F238E27FC236}">
+                <a16:creationId xmlns:a16="http://schemas.microsoft.com/office/drawing/2014/main" id="{83DDA7C1-6D6A-6978-ECCA-008BEF610626}"/>
+              </a:ext>
+            </a:extLst>
+          </p:cNvPr>
+          <p:cNvPicPr>
+            <a:picLocks noChangeAspect="1"/>
+          </p:cNvPicPr>
+          <p:nvPr/>
+        </p:nvPicPr>
+        <p:blipFill>
+          <a:blip r:embed="rId3">
+            <a:extLst>
+              <a:ext uri="{28A0092B-C50C-407E-A947-70E740481C1C}">
+                <a14:useLocalDpi xmlns:a14="http://schemas.microsoft.com/office/drawing/2010/main" val="0"/>
+              </a:ext>
+            </a:extLst>
+          </a:blip>
+          <a:srcRect r="96484"/>
+          <a:stretch>
+            <a:fillRect/>
+          </a:stretch>
+        </p:blipFill>
+        <p:spPr>
+          <a:xfrm>
+            <a:off x="82211" y="1117553"/>
+            <a:ext cx="967746" cy="4199032"/>
+          </a:xfrm>
+          <a:prstGeom prst="rect">
+            <a:avLst/>
+          </a:prstGeom>
+        </p:spPr>
+      </p:pic>
+      <p:pic>
+        <p:nvPicPr>
+          <p:cNvPr id="9" name="Content Placeholder 4">
+            <a:extLst>
+              <a:ext uri="{FF2B5EF4-FFF2-40B4-BE49-F238E27FC236}">
+                <a16:creationId xmlns:a16="http://schemas.microsoft.com/office/drawing/2014/main" id="{24153208-FFC0-4EB9-F5EB-C9C8F164B7C5}"/>
+              </a:ext>
+            </a:extLst>
+          </p:cNvPr>
+          <p:cNvPicPr>
+            <a:picLocks noChangeAspect="1"/>
+          </p:cNvPicPr>
+          <p:nvPr/>
+        </p:nvPicPr>
+        <p:blipFill>
+          <a:blip r:embed="rId3">
+            <a:extLst>
+              <a:ext uri="{28A0092B-C50C-407E-A947-70E740481C1C}">
+                <a14:useLocalDpi xmlns:a14="http://schemas.microsoft.com/office/drawing/2010/main" val="0"/>
+              </a:ext>
+            </a:extLst>
+          </a:blip>
+          <a:srcRect l="90889" t="10166" r="2499" b="73802"/>
+          <a:stretch>
+            <a:fillRect/>
+          </a:stretch>
+        </p:blipFill>
+        <p:spPr>
+          <a:xfrm>
+            <a:off x="8373618" y="1681162"/>
+            <a:ext cx="2768425" cy="1023938"/>
+          </a:xfrm>
+          <a:prstGeom prst="rect">
+            <a:avLst/>
+          </a:prstGeom>
+        </p:spPr>
+      </p:pic>
+      <p:pic>
+        <p:nvPicPr>
+          <p:cNvPr id="12" name="Picture 11">
+            <a:extLst>
+              <a:ext uri="{FF2B5EF4-FFF2-40B4-BE49-F238E27FC236}">
+                <a16:creationId xmlns:a16="http://schemas.microsoft.com/office/drawing/2014/main" id="{207BA257-2D46-A1D8-123A-D8D7F72CFF12}"/>
+              </a:ext>
+            </a:extLst>
+          </p:cNvPr>
+          <p:cNvPicPr>
+            <a:picLocks noChangeAspect="1"/>
+          </p:cNvPicPr>
+          <p:nvPr/>
+        </p:nvPicPr>
+        <p:blipFill>
+          <a:blip r:embed="rId3">
+            <a:extLst>
+              <a:ext uri="{28A0092B-C50C-407E-A947-70E740481C1C}">
+                <a14:useLocalDpi xmlns:a14="http://schemas.microsoft.com/office/drawing/2010/main" val="0"/>
+              </a:ext>
+            </a:extLst>
+          </a:blip>
+          <a:srcRect l="97463"/>
+          <a:stretch>
+            <a:fillRect/>
+          </a:stretch>
+        </p:blipFill>
+        <p:spPr>
+          <a:xfrm>
+            <a:off x="11216307" y="1120129"/>
+            <a:ext cx="698500" cy="4196456"/>
+          </a:xfrm>
+          <a:prstGeom prst="rect">
+            <a:avLst/>
+          </a:prstGeom>
+        </p:spPr>
+      </p:pic>
+      <p:pic>
+        <p:nvPicPr>
+          <p:cNvPr id="13" name="Picture 12">
+            <a:extLst>
+              <a:ext uri="{FF2B5EF4-FFF2-40B4-BE49-F238E27FC236}">
+                <a16:creationId xmlns:a16="http://schemas.microsoft.com/office/drawing/2014/main" id="{3AEA77FA-7C4C-39C7-61DF-7EE3DEECBAC0}"/>
+              </a:ext>
+            </a:extLst>
+          </p:cNvPr>
+          <p:cNvPicPr>
+            <a:picLocks noChangeAspect="1"/>
+          </p:cNvPicPr>
+          <p:nvPr/>
+        </p:nvPicPr>
+        <p:blipFill>
+          <a:blip r:embed="rId3">
+            <a:extLst>
+              <a:ext uri="{28A0092B-C50C-407E-A947-70E740481C1C}">
+                <a14:useLocalDpi xmlns:a14="http://schemas.microsoft.com/office/drawing/2010/main" val="0"/>
+              </a:ext>
+            </a:extLst>
+          </a:blip>
+          <a:srcRect l="48828" t="86172" r="48047" b="5443"/>
+          <a:stretch>
+            <a:fillRect/>
+          </a:stretch>
+        </p:blipFill>
+        <p:spPr>
+          <a:xfrm>
+            <a:off x="5649428" y="4929004"/>
+            <a:ext cx="893143" cy="365585"/>
+          </a:xfrm>
+          <a:prstGeom prst="rect">
+            <a:avLst/>
+          </a:prstGeom>
+        </p:spPr>
+      </p:pic>
     </p:spTree>
     <p:extLst>
       <p:ext uri="{BB962C8B-B14F-4D97-AF65-F5344CB8AC3E}">
         <p14:creationId xmlns:p14="http://schemas.microsoft.com/office/powerpoint/2010/main" val="2477247370"/>
+      </p:ext>
+    </p:extLst>
+  </p:cSld>
+  <p:clrMapOvr>
+    <a:masterClrMapping/>
+  </p:clrMapOvr>
+</p:sld>
+</file>
+
+<file path=ppt/slides/slide4.xml><?xml version="1.0" encoding="utf-8"?>
+<p:sld xmlns:a="http://schemas.openxmlformats.org/drawingml/2006/main" xmlns:r="http://schemas.openxmlformats.org/officeDocument/2006/relationships" xmlns:p="http://schemas.openxmlformats.org/presentationml/2006/main">
+  <p:cSld>
+    <p:spTree>
+      <p:nvGrpSpPr>
+        <p:cNvPr id="1" name=""/>
+        <p:cNvGrpSpPr/>
+        <p:nvPr/>
+      </p:nvGrpSpPr>
+      <p:grpSpPr>
+        <a:xfrm>
+          <a:off x="0" y="0"/>
+          <a:ext cx="0" cy="0"/>
+          <a:chOff x="0" y="0"/>
+          <a:chExt cx="0" cy="0"/>
+        </a:xfrm>
+      </p:grpSpPr>
+      <p:sp>
+        <p:nvSpPr>
+          <p:cNvPr id="2" name="Title 1">
+            <a:extLst>
+              <a:ext uri="{FF2B5EF4-FFF2-40B4-BE49-F238E27FC236}">
+                <a16:creationId xmlns:a16="http://schemas.microsoft.com/office/drawing/2014/main" id="{05737532-B422-93F9-7B6B-FB6FD4D506F8}"/>
+              </a:ext>
+            </a:extLst>
+          </p:cNvPr>
+          <p:cNvSpPr>
+            <a:spLocks noGrp="1"/>
+          </p:cNvSpPr>
+          <p:nvPr>
+            <p:ph type="title"/>
+          </p:nvPr>
+        </p:nvSpPr>
+        <p:spPr/>
+        <p:txBody>
+          <a:bodyPr/>
+          <a:lstStyle/>
+          <a:p>
+            <a:endParaRPr lang="en-AU" dirty="0"/>
+          </a:p>
+        </p:txBody>
+      </p:sp>
+      <p:pic>
+        <p:nvPicPr>
+          <p:cNvPr id="5" name="Content Placeholder 4">
+            <a:extLst>
+              <a:ext uri="{FF2B5EF4-FFF2-40B4-BE49-F238E27FC236}">
+                <a16:creationId xmlns:a16="http://schemas.microsoft.com/office/drawing/2014/main" id="{31025E42-F576-C60E-807D-D6A8B681EE2A}"/>
+              </a:ext>
+            </a:extLst>
+          </p:cNvPr>
+          <p:cNvPicPr>
+            <a:picLocks noGrp="1" noChangeAspect="1"/>
+          </p:cNvPicPr>
+          <p:nvPr>
+            <p:ph idx="1"/>
+          </p:nvPr>
+        </p:nvPicPr>
+        <p:blipFill>
+          <a:blip r:embed="rId2">
+            <a:extLst>
+              <a:ext uri="{28A0092B-C50C-407E-A947-70E740481C1C}">
+                <a14:useLocalDpi xmlns:a14="http://schemas.microsoft.com/office/drawing/2010/main" val="0"/>
+              </a:ext>
+            </a:extLst>
+          </a:blip>
+          <a:srcRect l="90889" t="10166" r="2499" b="73802"/>
+          <a:stretch>
+            <a:fillRect/>
+          </a:stretch>
+        </p:blipFill>
+        <p:spPr>
+          <a:xfrm>
+            <a:off x="10396538" y="3357563"/>
+            <a:ext cx="695325" cy="257175"/>
+          </a:xfrm>
+        </p:spPr>
+      </p:pic>
+      <p:pic>
+        <p:nvPicPr>
+          <p:cNvPr id="7" name="Picture 6">
+            <a:extLst>
+              <a:ext uri="{FF2B5EF4-FFF2-40B4-BE49-F238E27FC236}">
+                <a16:creationId xmlns:a16="http://schemas.microsoft.com/office/drawing/2014/main" id="{8FE75A0E-092A-5630-FD89-B9138EE647C9}"/>
+              </a:ext>
+            </a:extLst>
+          </p:cNvPr>
+          <p:cNvPicPr>
+            <a:picLocks noChangeAspect="1"/>
+          </p:cNvPicPr>
+          <p:nvPr/>
+        </p:nvPicPr>
+        <p:blipFill>
+          <a:blip r:embed="rId2">
+            <a:extLst>
+              <a:ext uri="{28A0092B-C50C-407E-A947-70E740481C1C}">
+                <a14:useLocalDpi xmlns:a14="http://schemas.microsoft.com/office/drawing/2010/main" val="0"/>
+              </a:ext>
+            </a:extLst>
+          </a:blip>
+          <a:srcRect l="97463"/>
+          <a:stretch>
+            <a:fillRect/>
+          </a:stretch>
+        </p:blipFill>
+        <p:spPr>
+          <a:xfrm>
+            <a:off x="11882437" y="2499102"/>
+            <a:ext cx="309563" cy="1859796"/>
+          </a:xfrm>
+          <a:prstGeom prst="rect">
+            <a:avLst/>
+          </a:prstGeom>
+        </p:spPr>
+      </p:pic>
+      <p:pic>
+        <p:nvPicPr>
+          <p:cNvPr id="9" name="Picture 8">
+            <a:extLst>
+              <a:ext uri="{FF2B5EF4-FFF2-40B4-BE49-F238E27FC236}">
+                <a16:creationId xmlns:a16="http://schemas.microsoft.com/office/drawing/2014/main" id="{FDB02B5E-A6EE-18D3-B594-725950A1D29A}"/>
+              </a:ext>
+            </a:extLst>
+          </p:cNvPr>
+          <p:cNvPicPr>
+            <a:picLocks noChangeAspect="1"/>
+          </p:cNvPicPr>
+          <p:nvPr/>
+        </p:nvPicPr>
+        <p:blipFill>
+          <a:blip r:embed="rId2">
+            <a:extLst>
+              <a:ext uri="{28A0092B-C50C-407E-A947-70E740481C1C}">
+                <a14:useLocalDpi xmlns:a14="http://schemas.microsoft.com/office/drawing/2010/main" val="0"/>
+              </a:ext>
+            </a:extLst>
+          </a:blip>
+          <a:srcRect l="48828" t="86172" r="48047" b="5443"/>
+          <a:stretch>
+            <a:fillRect/>
+          </a:stretch>
+        </p:blipFill>
+        <p:spPr>
+          <a:xfrm>
+            <a:off x="5953124" y="4101722"/>
+            <a:ext cx="381001" cy="155953"/>
+          </a:xfrm>
+          <a:prstGeom prst="rect">
+            <a:avLst/>
+          </a:prstGeom>
+        </p:spPr>
+      </p:pic>
+    </p:spTree>
+    <p:extLst>
+      <p:ext uri="{BB962C8B-B14F-4D97-AF65-F5344CB8AC3E}">
+        <p14:creationId xmlns:p14="http://schemas.microsoft.com/office/powerpoint/2010/main" val="4209068504"/>
+      </p:ext>
+    </p:extLst>
+  </p:cSld>
+  <p:clrMapOvr>
+    <a:masterClrMapping/>
+  </p:clrMapOvr>
+</p:sld>
+</file>
+
+<file path=ppt/slides/slide5.xml><?xml version="1.0" encoding="utf-8"?>
+<p:sld xmlns:a="http://schemas.openxmlformats.org/drawingml/2006/main" xmlns:r="http://schemas.openxmlformats.org/officeDocument/2006/relationships" xmlns:p="http://schemas.openxmlformats.org/presentationml/2006/main">
+  <p:cSld>
+    <p:spTree>
+      <p:nvGrpSpPr>
+        <p:cNvPr id="1" name=""/>
+        <p:cNvGrpSpPr/>
+        <p:nvPr/>
+      </p:nvGrpSpPr>
+      <p:grpSpPr>
+        <a:xfrm>
+          <a:off x="0" y="0"/>
+          <a:ext cx="0" cy="0"/>
+          <a:chOff x="0" y="0"/>
+          <a:chExt cx="0" cy="0"/>
+        </a:xfrm>
+      </p:grpSpPr>
+      <p:pic>
+        <p:nvPicPr>
+          <p:cNvPr id="5" name="Content Placeholder 4">
+            <a:extLst>
+              <a:ext uri="{FF2B5EF4-FFF2-40B4-BE49-F238E27FC236}">
+                <a16:creationId xmlns:a16="http://schemas.microsoft.com/office/drawing/2014/main" id="{1FCE73BA-B036-19C8-B94A-7F26F9A8C040}"/>
+              </a:ext>
+            </a:extLst>
+          </p:cNvPr>
+          <p:cNvPicPr>
+            <a:picLocks noGrp="1" noChangeAspect="1"/>
+          </p:cNvPicPr>
+          <p:nvPr>
+            <p:ph idx="1"/>
+          </p:nvPr>
+        </p:nvPicPr>
+        <p:blipFill>
+          <a:blip r:embed="rId2">
+            <a:extLst>
+              <a:ext uri="{28A0092B-C50C-407E-A947-70E740481C1C}">
+                <a14:useLocalDpi xmlns:a14="http://schemas.microsoft.com/office/drawing/2010/main" val="0"/>
+              </a:ext>
+            </a:extLst>
+          </a:blip>
+          <a:srcRect l="41147" r="24845" b="63900"/>
+          <a:stretch>
+            <a:fillRect/>
+          </a:stretch>
+        </p:blipFill>
+        <p:spPr>
+          <a:xfrm>
+            <a:off x="3403159" y="1406560"/>
+            <a:ext cx="5087554" cy="4063933"/>
+          </a:xfrm>
+        </p:spPr>
+      </p:pic>
+      <p:sp>
+        <p:nvSpPr>
+          <p:cNvPr id="6" name="Rectangle 5">
+            <a:extLst>
+              <a:ext uri="{FF2B5EF4-FFF2-40B4-BE49-F238E27FC236}">
+                <a16:creationId xmlns:a16="http://schemas.microsoft.com/office/drawing/2014/main" id="{86814FB3-3228-2273-99F5-B62C5AA15DCD}"/>
+              </a:ext>
+            </a:extLst>
+          </p:cNvPr>
+          <p:cNvSpPr/>
+          <p:nvPr/>
+        </p:nvSpPr>
+        <p:spPr>
+          <a:xfrm>
+            <a:off x="4651513" y="1586285"/>
+            <a:ext cx="238539" cy="326003"/>
+          </a:xfrm>
+          <a:prstGeom prst="rect">
+            <a:avLst/>
+          </a:prstGeom>
+          <a:solidFill>
+            <a:srgbClr val="FFFFFF"/>
+          </a:solidFill>
+          <a:ln>
+            <a:noFill/>
+          </a:ln>
+        </p:spPr>
+        <p:style>
+          <a:lnRef idx="2">
+            <a:schemeClr val="accent1">
+              <a:shade val="15000"/>
+            </a:schemeClr>
+          </a:lnRef>
+          <a:fillRef idx="1">
+            <a:schemeClr val="accent1"/>
+          </a:fillRef>
+          <a:effectRef idx="0">
+            <a:schemeClr val="accent1"/>
+          </a:effectRef>
+          <a:fontRef idx="minor">
+            <a:schemeClr val="lt1"/>
+          </a:fontRef>
+        </p:style>
+        <p:txBody>
+          <a:bodyPr rtlCol="0" anchor="ctr"/>
+          <a:lstStyle/>
+          <a:p>
+            <a:pPr algn="ctr"/>
+            <a:endParaRPr lang="en-AU"/>
+          </a:p>
+        </p:txBody>
+      </p:sp>
+      <p:sp>
+        <p:nvSpPr>
+          <p:cNvPr id="7" name="Rectangle 6">
+            <a:extLst>
+              <a:ext uri="{FF2B5EF4-FFF2-40B4-BE49-F238E27FC236}">
+                <a16:creationId xmlns:a16="http://schemas.microsoft.com/office/drawing/2014/main" id="{2B8CB6DE-7289-D4BB-5953-67B778AEA9DB}"/>
+              </a:ext>
+            </a:extLst>
+          </p:cNvPr>
+          <p:cNvSpPr/>
+          <p:nvPr/>
+        </p:nvSpPr>
+        <p:spPr>
+          <a:xfrm>
+            <a:off x="4954987" y="5125437"/>
+            <a:ext cx="793806" cy="326003"/>
+          </a:xfrm>
+          <a:prstGeom prst="rect">
+            <a:avLst/>
+          </a:prstGeom>
+          <a:solidFill>
+            <a:srgbClr val="FFFFFF"/>
+          </a:solidFill>
+          <a:ln>
+            <a:noFill/>
+          </a:ln>
+        </p:spPr>
+        <p:style>
+          <a:lnRef idx="2">
+            <a:schemeClr val="accent1">
+              <a:shade val="15000"/>
+            </a:schemeClr>
+          </a:lnRef>
+          <a:fillRef idx="1">
+            <a:schemeClr val="accent1"/>
+          </a:fillRef>
+          <a:effectRef idx="0">
+            <a:schemeClr val="accent1"/>
+          </a:effectRef>
+          <a:fontRef idx="minor">
+            <a:schemeClr val="lt1"/>
+          </a:fontRef>
+        </p:style>
+        <p:txBody>
+          <a:bodyPr rtlCol="0" anchor="ctr"/>
+          <a:lstStyle/>
+          <a:p>
+            <a:pPr algn="ctr"/>
+            <a:endParaRPr lang="en-AU"/>
+          </a:p>
+        </p:txBody>
+      </p:sp>
+      <p:pic>
+        <p:nvPicPr>
+          <p:cNvPr id="9" name="Picture 8">
+            <a:extLst>
+              <a:ext uri="{FF2B5EF4-FFF2-40B4-BE49-F238E27FC236}">
+                <a16:creationId xmlns:a16="http://schemas.microsoft.com/office/drawing/2014/main" id="{16D5D220-8069-58FD-6A5E-B8241B924959}"/>
+              </a:ext>
+            </a:extLst>
+          </p:cNvPr>
+          <p:cNvPicPr>
+            <a:picLocks noChangeAspect="1"/>
+          </p:cNvPicPr>
+          <p:nvPr/>
+        </p:nvPicPr>
+        <p:blipFill>
+          <a:blip r:embed="rId2">
+            <a:extLst>
+              <a:ext uri="{28A0092B-C50C-407E-A947-70E740481C1C}">
+                <a14:useLocalDpi xmlns:a14="http://schemas.microsoft.com/office/drawing/2010/main" val="0"/>
+              </a:ext>
+            </a:extLst>
+          </a:blip>
+          <a:srcRect l="4224" t="6609" r="89233" b="68348"/>
+          <a:stretch>
+            <a:fillRect/>
+          </a:stretch>
+        </p:blipFill>
+        <p:spPr>
+          <a:xfrm>
+            <a:off x="2464905" y="2151783"/>
+            <a:ext cx="979290" cy="2820360"/>
+          </a:xfrm>
+          <a:prstGeom prst="rect">
+            <a:avLst/>
+          </a:prstGeom>
+        </p:spPr>
+      </p:pic>
+      <p:pic>
+        <p:nvPicPr>
+          <p:cNvPr id="11" name="Picture 10">
+            <a:extLst>
+              <a:ext uri="{FF2B5EF4-FFF2-40B4-BE49-F238E27FC236}">
+                <a16:creationId xmlns:a16="http://schemas.microsoft.com/office/drawing/2014/main" id="{3CD51B88-68C6-F6F9-08F8-792C58D0E9DA}"/>
+              </a:ext>
+            </a:extLst>
+          </p:cNvPr>
+          <p:cNvPicPr>
+            <a:picLocks noChangeAspect="1"/>
+          </p:cNvPicPr>
+          <p:nvPr/>
+        </p:nvPicPr>
+        <p:blipFill>
+          <a:blip r:embed="rId2">
+            <a:extLst>
+              <a:ext uri="{28A0092B-C50C-407E-A947-70E740481C1C}">
+                <a14:useLocalDpi xmlns:a14="http://schemas.microsoft.com/office/drawing/2010/main" val="0"/>
+              </a:ext>
+            </a:extLst>
+          </a:blip>
+          <a:srcRect l="97367" b="66377"/>
+          <a:stretch>
+            <a:fillRect/>
+          </a:stretch>
+        </p:blipFill>
+        <p:spPr>
+          <a:xfrm>
+            <a:off x="8496180" y="1408207"/>
+            <a:ext cx="393377" cy="3780133"/>
+          </a:xfrm>
+          <a:prstGeom prst="rect">
+            <a:avLst/>
+          </a:prstGeom>
+        </p:spPr>
+      </p:pic>
+      <p:pic>
+        <p:nvPicPr>
+          <p:cNvPr id="13" name="Picture 12">
+            <a:extLst>
+              <a:ext uri="{FF2B5EF4-FFF2-40B4-BE49-F238E27FC236}">
+                <a16:creationId xmlns:a16="http://schemas.microsoft.com/office/drawing/2014/main" id="{8A1BE2BC-2051-A542-AEF6-C17DA82A5B5B}"/>
+              </a:ext>
+            </a:extLst>
+          </p:cNvPr>
+          <p:cNvPicPr>
+            <a:picLocks noChangeAspect="1"/>
+          </p:cNvPicPr>
+          <p:nvPr/>
+        </p:nvPicPr>
+        <p:blipFill>
+          <a:blip r:embed="rId2">
+            <a:extLst>
+              <a:ext uri="{28A0092B-C50C-407E-A947-70E740481C1C}">
+                <a14:useLocalDpi xmlns:a14="http://schemas.microsoft.com/office/drawing/2010/main" val="0"/>
+              </a:ext>
+            </a:extLst>
+          </a:blip>
+          <a:srcRect l="78060" t="70990" r="2576" b="17546"/>
+          <a:stretch>
+            <a:fillRect/>
+          </a:stretch>
+        </p:blipFill>
+        <p:spPr>
+          <a:xfrm>
+            <a:off x="3682092" y="3984171"/>
+            <a:ext cx="1649187" cy="734786"/>
+          </a:xfrm>
+          <a:prstGeom prst="rect">
+            <a:avLst/>
+          </a:prstGeom>
+        </p:spPr>
+      </p:pic>
+      <p:pic>
+        <p:nvPicPr>
+          <p:cNvPr id="14" name="Picture 13">
+            <a:extLst>
+              <a:ext uri="{FF2B5EF4-FFF2-40B4-BE49-F238E27FC236}">
+                <a16:creationId xmlns:a16="http://schemas.microsoft.com/office/drawing/2014/main" id="{B124C1AB-FF21-9B1F-0E57-44154A9D5C81}"/>
+              </a:ext>
+            </a:extLst>
+          </p:cNvPr>
+          <p:cNvPicPr>
+            <a:picLocks noChangeAspect="1"/>
+          </p:cNvPicPr>
+          <p:nvPr/>
+        </p:nvPicPr>
+        <p:blipFill>
+          <a:blip r:embed="rId3">
+            <a:extLst>
+              <a:ext uri="{28A0092B-C50C-407E-A947-70E740481C1C}">
+                <a14:useLocalDpi xmlns:a14="http://schemas.microsoft.com/office/drawing/2010/main" val="0"/>
+              </a:ext>
+            </a:extLst>
+          </a:blip>
+          <a:srcRect l="48828" t="86172" r="48047" b="5443"/>
+          <a:stretch>
+            <a:fillRect/>
+          </a:stretch>
+        </p:blipFill>
+        <p:spPr>
+          <a:xfrm>
+            <a:off x="5649428" y="5125437"/>
+            <a:ext cx="893143" cy="365585"/>
+          </a:xfrm>
+          <a:prstGeom prst="rect">
+            <a:avLst/>
+          </a:prstGeom>
+        </p:spPr>
+      </p:pic>
+    </p:spTree>
+    <p:extLst>
+      <p:ext uri="{BB962C8B-B14F-4D97-AF65-F5344CB8AC3E}">
+        <p14:creationId xmlns:p14="http://schemas.microsoft.com/office/powerpoint/2010/main" val="590550089"/>
+      </p:ext>
+    </p:extLst>
+  </p:cSld>
+  <p:clrMapOvr>
+    <a:masterClrMapping/>
+  </p:clrMapOvr>
+</p:sld>
+</file>
+
+<file path=ppt/slides/slide6.xml><?xml version="1.0" encoding="utf-8"?>
+<p:sld xmlns:a="http://schemas.openxmlformats.org/drawingml/2006/main" xmlns:r="http://schemas.openxmlformats.org/officeDocument/2006/relationships" xmlns:p="http://schemas.openxmlformats.org/presentationml/2006/main">
+  <p:cSld>
+    <p:spTree>
+      <p:nvGrpSpPr>
+        <p:cNvPr id="1" name=""/>
+        <p:cNvGrpSpPr/>
+        <p:nvPr/>
+      </p:nvGrpSpPr>
+      <p:grpSpPr>
+        <a:xfrm>
+          <a:off x="0" y="0"/>
+          <a:ext cx="0" cy="0"/>
+          <a:chOff x="0" y="0"/>
+          <a:chExt cx="0" cy="0"/>
+        </a:xfrm>
+      </p:grpSpPr>
+      <p:sp>
+        <p:nvSpPr>
+          <p:cNvPr id="2" name="Title 1">
+            <a:extLst>
+              <a:ext uri="{FF2B5EF4-FFF2-40B4-BE49-F238E27FC236}">
+                <a16:creationId xmlns:a16="http://schemas.microsoft.com/office/drawing/2014/main" id="{E766C162-E01E-801B-1724-CAF75A9088CA}"/>
+              </a:ext>
+            </a:extLst>
+          </p:cNvPr>
+          <p:cNvSpPr>
+            <a:spLocks noGrp="1"/>
+          </p:cNvSpPr>
+          <p:nvPr>
+            <p:ph type="title"/>
+          </p:nvPr>
+        </p:nvSpPr>
+        <p:spPr/>
+        <p:txBody>
+          <a:bodyPr/>
+          <a:lstStyle/>
+          <a:p>
+            <a:endParaRPr lang="en-AU"/>
+          </a:p>
+        </p:txBody>
+      </p:sp>
+      <p:pic>
+        <p:nvPicPr>
+          <p:cNvPr id="5" name="Content Placeholder 4">
+            <a:extLst>
+              <a:ext uri="{FF2B5EF4-FFF2-40B4-BE49-F238E27FC236}">
+                <a16:creationId xmlns:a16="http://schemas.microsoft.com/office/drawing/2014/main" id="{EBEF35EA-D892-83CF-CBBF-5517311F5201}"/>
+              </a:ext>
+            </a:extLst>
+          </p:cNvPr>
+          <p:cNvPicPr>
+            <a:picLocks noGrp="1" noChangeAspect="1"/>
+          </p:cNvPicPr>
+          <p:nvPr>
+            <p:ph idx="1"/>
+          </p:nvPr>
+        </p:nvPicPr>
+        <p:blipFill>
+          <a:blip r:embed="rId2">
+            <a:extLst>
+              <a:ext uri="{28A0092B-C50C-407E-A947-70E740481C1C}">
+                <a14:useLocalDpi xmlns:a14="http://schemas.microsoft.com/office/drawing/2010/main" val="0"/>
+              </a:ext>
+            </a:extLst>
+          </a:blip>
+          <a:srcRect l="313" t="48159"/>
+          <a:stretch>
+            <a:fillRect/>
+          </a:stretch>
+        </p:blipFill>
+        <p:spPr>
+          <a:xfrm>
+            <a:off x="838200" y="2011681"/>
+            <a:ext cx="5065875" cy="3688204"/>
+          </a:xfrm>
+        </p:spPr>
+      </p:pic>
+      <p:grpSp>
+        <p:nvGrpSpPr>
+          <p:cNvPr id="10" name="Group 9">
+            <a:extLst>
+              <a:ext uri="{FF2B5EF4-FFF2-40B4-BE49-F238E27FC236}">
+                <a16:creationId xmlns:a16="http://schemas.microsoft.com/office/drawing/2014/main" id="{0B10C5FC-FE21-171F-2584-C896BB450A30}"/>
+              </a:ext>
+            </a:extLst>
+          </p:cNvPr>
+          <p:cNvGrpSpPr/>
+          <p:nvPr/>
+        </p:nvGrpSpPr>
+        <p:grpSpPr>
+          <a:xfrm>
+            <a:off x="5773083" y="1908873"/>
+            <a:ext cx="5143504" cy="3893819"/>
+            <a:chOff x="6370315" y="2011681"/>
+            <a:chExt cx="4572009" cy="3402469"/>
+          </a:xfrm>
+        </p:grpSpPr>
+        <p:pic>
+          <p:nvPicPr>
+            <p:cNvPr id="7" name="Picture 6">
+              <a:extLst>
+                <a:ext uri="{FF2B5EF4-FFF2-40B4-BE49-F238E27FC236}">
+                  <a16:creationId xmlns:a16="http://schemas.microsoft.com/office/drawing/2014/main" id="{F3930166-0878-4D3C-15D8-33674E0F1BA3}"/>
+                </a:ext>
+              </a:extLst>
+            </p:cNvPr>
+            <p:cNvPicPr>
+              <a:picLocks noChangeAspect="1"/>
+            </p:cNvPicPr>
+            <p:nvPr/>
+          </p:nvPicPr>
+          <p:blipFill>
+            <a:blip r:embed="rId2">
+              <a:extLst>
+                <a:ext uri="{28A0092B-C50C-407E-A947-70E740481C1C}">
+                  <a14:useLocalDpi xmlns:a14="http://schemas.microsoft.com/office/drawing/2010/main" val="0"/>
+                </a:ext>
+              </a:extLst>
+            </a:blip>
+            <a:srcRect b="52391"/>
+            <a:stretch>
+              <a:fillRect/>
+            </a:stretch>
+          </p:blipFill>
+          <p:spPr>
+            <a:xfrm>
+              <a:off x="6370315" y="2011681"/>
+              <a:ext cx="4572009" cy="3047344"/>
+            </a:xfrm>
+            <a:prstGeom prst="rect">
+              <a:avLst/>
+            </a:prstGeom>
+          </p:spPr>
+        </p:pic>
+        <p:pic>
+          <p:nvPicPr>
+            <p:cNvPr id="9" name="Picture 8">
+              <a:extLst>
+                <a:ext uri="{FF2B5EF4-FFF2-40B4-BE49-F238E27FC236}">
+                  <a16:creationId xmlns:a16="http://schemas.microsoft.com/office/drawing/2014/main" id="{48F79A34-9E60-0237-0625-6BD58CF6AB21}"/>
+                </a:ext>
+              </a:extLst>
+            </p:cNvPr>
+            <p:cNvPicPr>
+              <a:picLocks noChangeAspect="1"/>
+            </p:cNvPicPr>
+            <p:nvPr/>
+          </p:nvPicPr>
+          <p:blipFill>
+            <a:blip r:embed="rId2">
+              <a:extLst>
+                <a:ext uri="{28A0092B-C50C-407E-A947-70E740481C1C}">
+                  <a14:useLocalDpi xmlns:a14="http://schemas.microsoft.com/office/drawing/2010/main" val="0"/>
+                </a:ext>
+              </a:extLst>
+            </a:blip>
+            <a:srcRect l="21084" t="92205" r="-1"/>
+            <a:stretch>
+              <a:fillRect/>
+            </a:stretch>
+          </p:blipFill>
+          <p:spPr>
+            <a:xfrm>
+              <a:off x="7334250" y="4915200"/>
+              <a:ext cx="3608074" cy="498950"/>
+            </a:xfrm>
+            <a:prstGeom prst="rect">
+              <a:avLst/>
+            </a:prstGeom>
+          </p:spPr>
+        </p:pic>
+      </p:grpSp>
+    </p:spTree>
+    <p:extLst>
+      <p:ext uri="{BB962C8B-B14F-4D97-AF65-F5344CB8AC3E}">
+        <p14:creationId xmlns:p14="http://schemas.microsoft.com/office/powerpoint/2010/main" val="305237080"/>
+      </p:ext>
+    </p:extLst>
+  </p:cSld>
+  <p:clrMapOvr>
+    <a:masterClrMapping/>
+  </p:clrMapOvr>
+</p:sld>
+</file>
+
+<file path=ppt/slides/slide7.xml><?xml version="1.0" encoding="utf-8"?>
+<p:sld xmlns:a="http://schemas.openxmlformats.org/drawingml/2006/main" xmlns:r="http://schemas.openxmlformats.org/officeDocument/2006/relationships" xmlns:p="http://schemas.openxmlformats.org/presentationml/2006/main">
+  <p:cSld>
+    <p:spTree>
+      <p:nvGrpSpPr>
+        <p:cNvPr id="1" name=""/>
+        <p:cNvGrpSpPr/>
+        <p:nvPr/>
+      </p:nvGrpSpPr>
+      <p:grpSpPr>
+        <a:xfrm>
+          <a:off x="0" y="0"/>
+          <a:ext cx="0" cy="0"/>
+          <a:chOff x="0" y="0"/>
+          <a:chExt cx="0" cy="0"/>
+        </a:xfrm>
+      </p:grpSpPr>
+      <p:pic>
+        <p:nvPicPr>
+          <p:cNvPr id="5" name="Content Placeholder 4">
+            <a:extLst>
+              <a:ext uri="{FF2B5EF4-FFF2-40B4-BE49-F238E27FC236}">
+                <a16:creationId xmlns:a16="http://schemas.microsoft.com/office/drawing/2014/main" id="{323EC345-A083-0CF3-4F72-3AE929EE1813}"/>
+              </a:ext>
+            </a:extLst>
+          </p:cNvPr>
+          <p:cNvPicPr>
+            <a:picLocks noGrp="1" noChangeAspect="1"/>
+          </p:cNvPicPr>
+          <p:nvPr>
+            <p:ph idx="1"/>
+          </p:nvPr>
+        </p:nvPicPr>
+        <p:blipFill>
+          <a:blip r:embed="rId2">
+            <a:extLst>
+              <a:ext uri="{28A0092B-C50C-407E-A947-70E740481C1C}">
+                <a14:useLocalDpi xmlns:a14="http://schemas.microsoft.com/office/drawing/2010/main" val="0"/>
+              </a:ext>
+            </a:extLst>
+          </a:blip>
+          <a:stretch>
+            <a:fillRect/>
+          </a:stretch>
+        </p:blipFill>
+        <p:spPr>
+          <a:xfrm>
+            <a:off x="7302494" y="3716354"/>
+            <a:ext cx="4225354" cy="3033804"/>
+          </a:xfrm>
+        </p:spPr>
+      </p:pic>
+      <p:pic>
+        <p:nvPicPr>
+          <p:cNvPr id="7" name="Picture 6">
+            <a:extLst>
+              <a:ext uri="{FF2B5EF4-FFF2-40B4-BE49-F238E27FC236}">
+                <a16:creationId xmlns:a16="http://schemas.microsoft.com/office/drawing/2014/main" id="{BFB53650-6535-B9D3-9050-0F8A9FBFE684}"/>
+              </a:ext>
+            </a:extLst>
+          </p:cNvPr>
+          <p:cNvPicPr>
+            <a:picLocks noChangeAspect="1"/>
+          </p:cNvPicPr>
+          <p:nvPr/>
+        </p:nvPicPr>
+        <p:blipFill>
+          <a:blip r:embed="rId3">
+            <a:extLst>
+              <a:ext uri="{28A0092B-C50C-407E-A947-70E740481C1C}">
+                <a14:useLocalDpi xmlns:a14="http://schemas.microsoft.com/office/drawing/2010/main" val="0"/>
+              </a:ext>
+            </a:extLst>
+          </a:blip>
+          <a:stretch>
+            <a:fillRect/>
+          </a:stretch>
+        </p:blipFill>
+        <p:spPr>
+          <a:xfrm>
+            <a:off x="100548" y="1340882"/>
+            <a:ext cx="4108480" cy="3673929"/>
+          </a:xfrm>
+          <a:prstGeom prst="rect">
+            <a:avLst/>
+          </a:prstGeom>
+        </p:spPr>
+      </p:pic>
+      <p:pic>
+        <p:nvPicPr>
+          <p:cNvPr id="9" name="Picture 8">
+            <a:extLst>
+              <a:ext uri="{FF2B5EF4-FFF2-40B4-BE49-F238E27FC236}">
+                <a16:creationId xmlns:a16="http://schemas.microsoft.com/office/drawing/2014/main" id="{5F775E3D-9101-5F5D-2B24-5D794F28C0A3}"/>
+              </a:ext>
+            </a:extLst>
+          </p:cNvPr>
+          <p:cNvPicPr>
+            <a:picLocks noChangeAspect="1"/>
+          </p:cNvPicPr>
+          <p:nvPr/>
+        </p:nvPicPr>
+        <p:blipFill>
+          <a:blip r:embed="rId4">
+            <a:extLst>
+              <a:ext uri="{28A0092B-C50C-407E-A947-70E740481C1C}">
+                <a14:useLocalDpi xmlns:a14="http://schemas.microsoft.com/office/drawing/2010/main" val="0"/>
+              </a:ext>
+            </a:extLst>
+          </a:blip>
+          <a:stretch>
+            <a:fillRect/>
+          </a:stretch>
+        </p:blipFill>
+        <p:spPr>
+          <a:xfrm>
+            <a:off x="4416534" y="539250"/>
+            <a:ext cx="2766559" cy="2755689"/>
+          </a:xfrm>
+          <a:prstGeom prst="rect">
+            <a:avLst/>
+          </a:prstGeom>
+        </p:spPr>
+      </p:pic>
+      <p:pic>
+        <p:nvPicPr>
+          <p:cNvPr id="11" name="Picture 10">
+            <a:extLst>
+              <a:ext uri="{FF2B5EF4-FFF2-40B4-BE49-F238E27FC236}">
+                <a16:creationId xmlns:a16="http://schemas.microsoft.com/office/drawing/2014/main" id="{37F2B3C9-43E0-4F62-FB2A-32686C36737A}"/>
+              </a:ext>
+            </a:extLst>
+          </p:cNvPr>
+          <p:cNvPicPr>
+            <a:picLocks noChangeAspect="1"/>
+          </p:cNvPicPr>
+          <p:nvPr/>
+        </p:nvPicPr>
+        <p:blipFill>
+          <a:blip r:embed="rId5">
+            <a:extLst>
+              <a:ext uri="{28A0092B-C50C-407E-A947-70E740481C1C}">
+                <a14:useLocalDpi xmlns:a14="http://schemas.microsoft.com/office/drawing/2010/main" val="0"/>
+              </a:ext>
+            </a:extLst>
+          </a:blip>
+          <a:srcRect l="895" t="-1" r="1455" b="2090"/>
+          <a:stretch>
+            <a:fillRect/>
+          </a:stretch>
+        </p:blipFill>
+        <p:spPr>
+          <a:xfrm>
+            <a:off x="7302494" y="539250"/>
+            <a:ext cx="4108479" cy="2949432"/>
+          </a:xfrm>
+          <a:prstGeom prst="rect">
+            <a:avLst/>
+          </a:prstGeom>
+        </p:spPr>
+      </p:pic>
+      <p:pic>
+        <p:nvPicPr>
+          <p:cNvPr id="13" name="Picture 12">
+            <a:extLst>
+              <a:ext uri="{FF2B5EF4-FFF2-40B4-BE49-F238E27FC236}">
+                <a16:creationId xmlns:a16="http://schemas.microsoft.com/office/drawing/2014/main" id="{EA06B218-BA53-46EF-95A8-A4D0F491FC12}"/>
+              </a:ext>
+            </a:extLst>
+          </p:cNvPr>
+          <p:cNvPicPr>
+            <a:picLocks noChangeAspect="1"/>
+          </p:cNvPicPr>
+          <p:nvPr/>
+        </p:nvPicPr>
+        <p:blipFill>
+          <a:blip r:embed="rId6">
+            <a:extLst>
+              <a:ext uri="{28A0092B-C50C-407E-A947-70E740481C1C}">
+                <a14:useLocalDpi xmlns:a14="http://schemas.microsoft.com/office/drawing/2010/main" val="0"/>
+              </a:ext>
+            </a:extLst>
+          </a:blip>
+          <a:stretch>
+            <a:fillRect/>
+          </a:stretch>
+        </p:blipFill>
+        <p:spPr>
+          <a:xfrm>
+            <a:off x="4426625" y="3716354"/>
+            <a:ext cx="2766558" cy="2744732"/>
+          </a:xfrm>
+          <a:prstGeom prst="rect">
+            <a:avLst/>
+          </a:prstGeom>
+        </p:spPr>
+      </p:pic>
+      <p:cxnSp>
+        <p:nvCxnSpPr>
+          <p:cNvPr id="15" name="Straight Connector 14">
+            <a:extLst>
+              <a:ext uri="{FF2B5EF4-FFF2-40B4-BE49-F238E27FC236}">
+                <a16:creationId xmlns:a16="http://schemas.microsoft.com/office/drawing/2014/main" id="{56CB3617-A165-5329-8F28-E816AB337F1E}"/>
+              </a:ext>
+            </a:extLst>
+          </p:cNvPr>
+          <p:cNvCxnSpPr/>
+          <p:nvPr/>
+        </p:nvCxnSpPr>
+        <p:spPr>
+          <a:xfrm>
+            <a:off x="4930769" y="1340882"/>
+            <a:ext cx="1363436" cy="408214"/>
+          </a:xfrm>
+          <a:prstGeom prst="line">
+            <a:avLst/>
+          </a:prstGeom>
+          <a:ln w="38100">
+            <a:solidFill>
+              <a:srgbClr val="FF0000"/>
+            </a:solidFill>
+          </a:ln>
+        </p:spPr>
+        <p:style>
+          <a:lnRef idx="1">
+            <a:schemeClr val="accent2"/>
+          </a:lnRef>
+          <a:fillRef idx="0">
+            <a:schemeClr val="accent2"/>
+          </a:fillRef>
+          <a:effectRef idx="0">
+            <a:schemeClr val="accent2"/>
+          </a:effectRef>
+          <a:fontRef idx="minor">
+            <a:schemeClr val="tx1"/>
+          </a:fontRef>
+        </p:style>
+      </p:cxnSp>
+      <p:cxnSp>
+        <p:nvCxnSpPr>
+          <p:cNvPr id="16" name="Straight Connector 15">
+            <a:extLst>
+              <a:ext uri="{FF2B5EF4-FFF2-40B4-BE49-F238E27FC236}">
+                <a16:creationId xmlns:a16="http://schemas.microsoft.com/office/drawing/2014/main" id="{C82E6028-BD8F-31DA-FFD0-053FF03DB0E6}"/>
+              </a:ext>
+            </a:extLst>
+          </p:cNvPr>
+          <p:cNvCxnSpPr>
+            <a:cxnSpLocks/>
+          </p:cNvCxnSpPr>
+          <p:nvPr/>
+        </p:nvCxnSpPr>
+        <p:spPr>
+          <a:xfrm>
+            <a:off x="4972387" y="4754481"/>
+            <a:ext cx="1260022" cy="457200"/>
+          </a:xfrm>
+          <a:prstGeom prst="line">
+            <a:avLst/>
+          </a:prstGeom>
+          <a:ln w="38100">
+            <a:solidFill>
+              <a:srgbClr val="FF0000"/>
+            </a:solidFill>
+          </a:ln>
+        </p:spPr>
+        <p:style>
+          <a:lnRef idx="1">
+            <a:schemeClr val="accent2"/>
+          </a:lnRef>
+          <a:fillRef idx="0">
+            <a:schemeClr val="accent2"/>
+          </a:fillRef>
+          <a:effectRef idx="0">
+            <a:schemeClr val="accent2"/>
+          </a:effectRef>
+          <a:fontRef idx="minor">
+            <a:schemeClr val="tx1"/>
+          </a:fontRef>
+        </p:style>
+      </p:cxnSp>
+      <p:sp>
+        <p:nvSpPr>
+          <p:cNvPr id="27" name="TextBox 26">
+            <a:extLst>
+              <a:ext uri="{FF2B5EF4-FFF2-40B4-BE49-F238E27FC236}">
+                <a16:creationId xmlns:a16="http://schemas.microsoft.com/office/drawing/2014/main" id="{54239896-1E97-91C1-EEAD-3F0061CF3918}"/>
+              </a:ext>
+            </a:extLst>
+          </p:cNvPr>
+          <p:cNvSpPr txBox="1"/>
+          <p:nvPr/>
+        </p:nvSpPr>
+        <p:spPr>
+          <a:xfrm>
+            <a:off x="4426624" y="175396"/>
+            <a:ext cx="2371725" cy="369332"/>
+          </a:xfrm>
+          <a:prstGeom prst="rect">
+            <a:avLst/>
+          </a:prstGeom>
+          <a:noFill/>
+        </p:spPr>
+        <p:txBody>
+          <a:bodyPr wrap="square" rtlCol="0">
+            <a:spAutoFit/>
+          </a:bodyPr>
+          <a:lstStyle/>
+          <a:p>
+            <a:r>
+              <a:rPr lang="en-AU" dirty="0"/>
+              <a:t>2a)</a:t>
+            </a:r>
+          </a:p>
+        </p:txBody>
+      </p:sp>
+      <p:sp>
+        <p:nvSpPr>
+          <p:cNvPr id="28" name="TextBox 27">
+            <a:extLst>
+              <a:ext uri="{FF2B5EF4-FFF2-40B4-BE49-F238E27FC236}">
+                <a16:creationId xmlns:a16="http://schemas.microsoft.com/office/drawing/2014/main" id="{9D8DDD91-2F19-0080-D8B5-4541866B026B}"/>
+              </a:ext>
+            </a:extLst>
+          </p:cNvPr>
+          <p:cNvSpPr txBox="1"/>
+          <p:nvPr/>
+        </p:nvSpPr>
+        <p:spPr>
+          <a:xfrm>
+            <a:off x="7509999" y="211964"/>
+            <a:ext cx="2371725" cy="369332"/>
+          </a:xfrm>
+          <a:prstGeom prst="rect">
+            <a:avLst/>
+          </a:prstGeom>
+          <a:noFill/>
+        </p:spPr>
+        <p:txBody>
+          <a:bodyPr wrap="square" rtlCol="0">
+            <a:spAutoFit/>
+          </a:bodyPr>
+          <a:lstStyle/>
+          <a:p>
+            <a:r>
+              <a:rPr lang="en-AU" dirty="0"/>
+              <a:t>2b)</a:t>
+            </a:r>
+          </a:p>
+        </p:txBody>
+      </p:sp>
+      <p:sp>
+        <p:nvSpPr>
+          <p:cNvPr id="29" name="TextBox 28">
+            <a:extLst>
+              <a:ext uri="{FF2B5EF4-FFF2-40B4-BE49-F238E27FC236}">
+                <a16:creationId xmlns:a16="http://schemas.microsoft.com/office/drawing/2014/main" id="{158871ED-A162-69B3-31D0-55A50A9CE74F}"/>
+              </a:ext>
+            </a:extLst>
+          </p:cNvPr>
+          <p:cNvSpPr txBox="1"/>
+          <p:nvPr/>
+        </p:nvSpPr>
+        <p:spPr>
+          <a:xfrm>
+            <a:off x="7510000" y="3366072"/>
+            <a:ext cx="2371725" cy="369332"/>
+          </a:xfrm>
+          <a:prstGeom prst="rect">
+            <a:avLst/>
+          </a:prstGeom>
+          <a:noFill/>
+        </p:spPr>
+        <p:txBody>
+          <a:bodyPr wrap="square" rtlCol="0">
+            <a:spAutoFit/>
+          </a:bodyPr>
+          <a:lstStyle/>
+          <a:p>
+            <a:r>
+              <a:rPr lang="en-AU" dirty="0"/>
+              <a:t>3b)</a:t>
+            </a:r>
+          </a:p>
+        </p:txBody>
+      </p:sp>
+      <p:sp>
+        <p:nvSpPr>
+          <p:cNvPr id="30" name="TextBox 29">
+            <a:extLst>
+              <a:ext uri="{FF2B5EF4-FFF2-40B4-BE49-F238E27FC236}">
+                <a16:creationId xmlns:a16="http://schemas.microsoft.com/office/drawing/2014/main" id="{B1A8C538-76E6-C78E-E87A-C978E6E860D1}"/>
+              </a:ext>
+            </a:extLst>
+          </p:cNvPr>
+          <p:cNvSpPr txBox="1"/>
+          <p:nvPr/>
+        </p:nvSpPr>
+        <p:spPr>
+          <a:xfrm>
+            <a:off x="4416534" y="3347022"/>
+            <a:ext cx="2371725" cy="369332"/>
+          </a:xfrm>
+          <a:prstGeom prst="rect">
+            <a:avLst/>
+          </a:prstGeom>
+          <a:noFill/>
+        </p:spPr>
+        <p:txBody>
+          <a:bodyPr wrap="square" rtlCol="0">
+            <a:spAutoFit/>
+          </a:bodyPr>
+          <a:lstStyle/>
+          <a:p>
+            <a:r>
+              <a:rPr lang="en-AU" dirty="0"/>
+              <a:t>3a)</a:t>
+            </a:r>
+          </a:p>
+        </p:txBody>
+      </p:sp>
+      <p:sp>
+        <p:nvSpPr>
+          <p:cNvPr id="31" name="TextBox 30">
+            <a:extLst>
+              <a:ext uri="{FF2B5EF4-FFF2-40B4-BE49-F238E27FC236}">
+                <a16:creationId xmlns:a16="http://schemas.microsoft.com/office/drawing/2014/main" id="{D1CF1DC1-66E4-705E-D7B4-D4EB3081F6B2}"/>
+              </a:ext>
+            </a:extLst>
+          </p:cNvPr>
+          <p:cNvSpPr txBox="1"/>
+          <p:nvPr/>
+        </p:nvSpPr>
+        <p:spPr>
+          <a:xfrm>
+            <a:off x="100548" y="971550"/>
+            <a:ext cx="2371725" cy="369332"/>
+          </a:xfrm>
+          <a:prstGeom prst="rect">
+            <a:avLst/>
+          </a:prstGeom>
+          <a:noFill/>
+        </p:spPr>
+        <p:txBody>
+          <a:bodyPr wrap="square" rtlCol="0">
+            <a:spAutoFit/>
+          </a:bodyPr>
+          <a:lstStyle/>
+          <a:p>
+            <a:r>
+              <a:rPr lang="en-AU" dirty="0"/>
+              <a:t>1)</a:t>
+            </a:r>
+          </a:p>
+        </p:txBody>
+      </p:sp>
+    </p:spTree>
+    <p:extLst>
+      <p:ext uri="{BB962C8B-B14F-4D97-AF65-F5344CB8AC3E}">
+        <p14:creationId xmlns:p14="http://schemas.microsoft.com/office/powerpoint/2010/main" val="1979390409"/>
       </p:ext>
     </p:extLst>
   </p:cSld>

</xml_diff>

<commit_message>
- added AFM text and caption - fixed setup picture - filled out some questions - microfab should be done, Results and discussion is still left
</commit_message>
<xml_diff>
--- a/correcting presenatation.pptx
+++ b/correcting presenatation.pptx
@@ -203,7 +203,7 @@
           <a:p>
             <a:fld id="{64A89AAA-76F1-4CA0-80AA-F05F7132AB43}" type="datetimeFigureOut">
               <a:rPr lang="en-AU" smtClean="0"/>
-              <a:t>25/08/2025</a:t>
+              <a:t>29/08/2025</a:t>
             </a:fld>
             <a:endParaRPr lang="en-AU"/>
           </a:p>
@@ -788,7 +788,7 @@
           <a:p>
             <a:fld id="{09C86A1F-4A6D-428C-A8C7-676077E82A7D}" type="datetimeFigureOut">
               <a:rPr lang="en-AU" smtClean="0"/>
-              <a:t>25/08/2025</a:t>
+              <a:t>29/08/2025</a:t>
             </a:fld>
             <a:endParaRPr lang="en-AU"/>
           </a:p>
@@ -988,7 +988,7 @@
           <a:p>
             <a:fld id="{09C86A1F-4A6D-428C-A8C7-676077E82A7D}" type="datetimeFigureOut">
               <a:rPr lang="en-AU" smtClean="0"/>
-              <a:t>25/08/2025</a:t>
+              <a:t>29/08/2025</a:t>
             </a:fld>
             <a:endParaRPr lang="en-AU"/>
           </a:p>
@@ -1198,7 +1198,7 @@
           <a:p>
             <a:fld id="{09C86A1F-4A6D-428C-A8C7-676077E82A7D}" type="datetimeFigureOut">
               <a:rPr lang="en-AU" smtClean="0"/>
-              <a:t>25/08/2025</a:t>
+              <a:t>29/08/2025</a:t>
             </a:fld>
             <a:endParaRPr lang="en-AU"/>
           </a:p>
@@ -1398,7 +1398,7 @@
           <a:p>
             <a:fld id="{09C86A1F-4A6D-428C-A8C7-676077E82A7D}" type="datetimeFigureOut">
               <a:rPr lang="en-AU" smtClean="0"/>
-              <a:t>25/08/2025</a:t>
+              <a:t>29/08/2025</a:t>
             </a:fld>
             <a:endParaRPr lang="en-AU"/>
           </a:p>
@@ -1674,7 +1674,7 @@
           <a:p>
             <a:fld id="{09C86A1F-4A6D-428C-A8C7-676077E82A7D}" type="datetimeFigureOut">
               <a:rPr lang="en-AU" smtClean="0"/>
-              <a:t>25/08/2025</a:t>
+              <a:t>29/08/2025</a:t>
             </a:fld>
             <a:endParaRPr lang="en-AU"/>
           </a:p>
@@ -1942,7 +1942,7 @@
           <a:p>
             <a:fld id="{09C86A1F-4A6D-428C-A8C7-676077E82A7D}" type="datetimeFigureOut">
               <a:rPr lang="en-AU" smtClean="0"/>
-              <a:t>25/08/2025</a:t>
+              <a:t>29/08/2025</a:t>
             </a:fld>
             <a:endParaRPr lang="en-AU"/>
           </a:p>
@@ -2357,7 +2357,7 @@
           <a:p>
             <a:fld id="{09C86A1F-4A6D-428C-A8C7-676077E82A7D}" type="datetimeFigureOut">
               <a:rPr lang="en-AU" smtClean="0"/>
-              <a:t>25/08/2025</a:t>
+              <a:t>29/08/2025</a:t>
             </a:fld>
             <a:endParaRPr lang="en-AU"/>
           </a:p>
@@ -2499,7 +2499,7 @@
           <a:p>
             <a:fld id="{09C86A1F-4A6D-428C-A8C7-676077E82A7D}" type="datetimeFigureOut">
               <a:rPr lang="en-AU" smtClean="0"/>
-              <a:t>25/08/2025</a:t>
+              <a:t>29/08/2025</a:t>
             </a:fld>
             <a:endParaRPr lang="en-AU"/>
           </a:p>
@@ -2612,7 +2612,7 @@
           <a:p>
             <a:fld id="{09C86A1F-4A6D-428C-A8C7-676077E82A7D}" type="datetimeFigureOut">
               <a:rPr lang="en-AU" smtClean="0"/>
-              <a:t>25/08/2025</a:t>
+              <a:t>29/08/2025</a:t>
             </a:fld>
             <a:endParaRPr lang="en-AU"/>
           </a:p>
@@ -2925,7 +2925,7 @@
           <a:p>
             <a:fld id="{09C86A1F-4A6D-428C-A8C7-676077E82A7D}" type="datetimeFigureOut">
               <a:rPr lang="en-AU" smtClean="0"/>
-              <a:t>25/08/2025</a:t>
+              <a:t>29/08/2025</a:t>
             </a:fld>
             <a:endParaRPr lang="en-AU"/>
           </a:p>
@@ -3214,7 +3214,7 @@
           <a:p>
             <a:fld id="{09C86A1F-4A6D-428C-A8C7-676077E82A7D}" type="datetimeFigureOut">
               <a:rPr lang="en-AU" smtClean="0"/>
-              <a:t>25/08/2025</a:t>
+              <a:t>29/08/2025</a:t>
             </a:fld>
             <a:endParaRPr lang="en-AU"/>
           </a:p>
@@ -3457,7 +3457,7 @@
           <a:p>
             <a:fld id="{09C86A1F-4A6D-428C-A8C7-676077E82A7D}" type="datetimeFigureOut">
               <a:rPr lang="en-AU" smtClean="0"/>
-              <a:t>25/08/2025</a:t>
+              <a:t>29/08/2025</a:t>
             </a:fld>
             <a:endParaRPr lang="en-AU"/>
           </a:p>
@@ -3976,7 +3976,7 @@
         </p:nvSpPr>
         <p:spPr>
           <a:xfrm>
-            <a:off x="8678334" y="3584449"/>
+            <a:off x="8678334" y="3580847"/>
             <a:ext cx="1692888" cy="801283"/>
           </a:xfrm>
           <a:prstGeom prst="rect">
@@ -4013,7 +4013,7 @@
                   <a:schemeClr val="tx1"/>
                 </a:solidFill>
               </a:rPr>
-              <a:t>WAS WAR DAS NOCHMAL?</a:t>
+              <a:t>Series Resistance</a:t>
             </a:r>
           </a:p>
         </p:txBody>
@@ -4090,10 +4090,10 @@
       </p:sp>
       <p:sp>
         <p:nvSpPr>
-          <p:cNvPr id="8" name="Rectangle 7">
-            <a:extLst>
-              <a:ext uri="{FF2B5EF4-FFF2-40B4-BE49-F238E27FC236}">
-                <a16:creationId xmlns:a16="http://schemas.microsoft.com/office/drawing/2014/main" id="{AD8866DF-E1E8-25AC-236D-886EF28FDA03}"/>
+          <p:cNvPr id="9" name="Rectangle 8">
+            <a:extLst>
+              <a:ext uri="{FF2B5EF4-FFF2-40B4-BE49-F238E27FC236}">
+                <a16:creationId xmlns:a16="http://schemas.microsoft.com/office/drawing/2014/main" id="{1B9D6EB6-DBA3-E951-EA9F-C93E6A4A0DAF}"/>
               </a:ext>
             </a:extLst>
           </p:cNvPr>
@@ -4102,8 +4102,8 @@
         </p:nvSpPr>
         <p:spPr>
           <a:xfrm>
-            <a:off x="2695074" y="5077326"/>
-            <a:ext cx="1235242" cy="1299411"/>
+            <a:off x="3188472" y="2743200"/>
+            <a:ext cx="901594" cy="238125"/>
           </a:xfrm>
           <a:prstGeom prst="rect">
             <a:avLst/>
@@ -4111,6 +4111,9 @@
           <a:solidFill>
             <a:srgbClr val="94BD5E"/>
           </a:solidFill>
+          <a:ln>
+            <a:noFill/>
+          </a:ln>
         </p:spPr>
         <p:style>
           <a:lnRef idx="2">
@@ -4134,22 +4137,22 @@
           <a:p>
             <a:pPr algn="ctr"/>
             <a:r>
-              <a:rPr lang="en-AU" dirty="0">
+              <a:rPr lang="en-AU" sz="1600" dirty="0">
                 <a:solidFill>
                   <a:schemeClr val="tx1"/>
                 </a:solidFill>
               </a:rPr>
-              <a:t>Power Supply</a:t>
-            </a:r>
-          </a:p>
-        </p:txBody>
-      </p:sp>
-      <p:sp>
-        <p:nvSpPr>
-          <p:cNvPr id="9" name="Rectangle 8">
-            <a:extLst>
-              <a:ext uri="{FF2B5EF4-FFF2-40B4-BE49-F238E27FC236}">
-                <a16:creationId xmlns:a16="http://schemas.microsoft.com/office/drawing/2014/main" id="{1B9D6EB6-DBA3-E951-EA9F-C93E6A4A0DAF}"/>
+              <a:t>Solenoid</a:t>
+            </a:r>
+          </a:p>
+        </p:txBody>
+      </p:sp>
+      <p:sp>
+        <p:nvSpPr>
+          <p:cNvPr id="8" name="Rectangle 7">
+            <a:extLst>
+              <a:ext uri="{FF2B5EF4-FFF2-40B4-BE49-F238E27FC236}">
+                <a16:creationId xmlns:a16="http://schemas.microsoft.com/office/drawing/2014/main" id="{AD8866DF-E1E8-25AC-236D-886EF28FDA03}"/>
               </a:ext>
             </a:extLst>
           </p:cNvPr>
@@ -4158,8 +4161,8 @@
         </p:nvSpPr>
         <p:spPr>
           <a:xfrm>
-            <a:off x="3324924" y="2743200"/>
-            <a:ext cx="725582" cy="238125"/>
+            <a:off x="2695074" y="5077326"/>
+            <a:ext cx="1235242" cy="1299411"/>
           </a:xfrm>
           <a:prstGeom prst="rect">
             <a:avLst/>
@@ -4167,9 +4170,6 @@
           <a:solidFill>
             <a:srgbClr val="94BD5E"/>
           </a:solidFill>
-          <a:ln>
-            <a:noFill/>
-          </a:ln>
         </p:spPr>
         <p:style>
           <a:lnRef idx="2">
@@ -4198,17 +4198,17 @@
                   <a:schemeClr val="tx1"/>
                 </a:solidFill>
               </a:rPr>
-              <a:t>Coil</a:t>
-            </a:r>
-          </a:p>
-        </p:txBody>
-      </p:sp>
-      <p:sp>
-        <p:nvSpPr>
-          <p:cNvPr id="16" name="Freeform: Shape 15">
-            <a:extLst>
-              <a:ext uri="{FF2B5EF4-FFF2-40B4-BE49-F238E27FC236}">
-                <a16:creationId xmlns:a16="http://schemas.microsoft.com/office/drawing/2014/main" id="{68B91B7E-2E2F-FDEC-3CD5-1B0F4BC52A01}"/>
+              <a:t>Power Supply</a:t>
+            </a:r>
+          </a:p>
+        </p:txBody>
+      </p:sp>
+      <p:sp>
+        <p:nvSpPr>
+          <p:cNvPr id="17" name="Rectangle 16">
+            <a:extLst>
+              <a:ext uri="{FF2B5EF4-FFF2-40B4-BE49-F238E27FC236}">
+                <a16:creationId xmlns:a16="http://schemas.microsoft.com/office/drawing/2014/main" id="{74DEB147-FDB5-25EF-B5BA-A97A1AFF8B86}"/>
               </a:ext>
             </a:extLst>
           </p:cNvPr>
@@ -4217,8 +4217,888 @@
         </p:nvSpPr>
         <p:spPr>
           <a:xfrm>
-            <a:off x="3930316" y="2952750"/>
-            <a:ext cx="143848" cy="48759"/>
+            <a:off x="5788550" y="2644574"/>
+            <a:ext cx="958410" cy="351366"/>
+          </a:xfrm>
+          <a:prstGeom prst="rect">
+            <a:avLst/>
+          </a:prstGeom>
+          <a:solidFill>
+            <a:srgbClr val="94BD5E"/>
+          </a:solidFill>
+          <a:ln>
+            <a:noFill/>
+          </a:ln>
+        </p:spPr>
+        <p:style>
+          <a:lnRef idx="2">
+            <a:schemeClr val="accent1">
+              <a:shade val="15000"/>
+            </a:schemeClr>
+          </a:lnRef>
+          <a:fillRef idx="1">
+            <a:schemeClr val="accent1"/>
+          </a:fillRef>
+          <a:effectRef idx="0">
+            <a:schemeClr val="accent1"/>
+          </a:effectRef>
+          <a:fontRef idx="minor">
+            <a:schemeClr val="lt1"/>
+          </a:fontRef>
+        </p:style>
+        <p:txBody>
+          <a:bodyPr rtlCol="0" anchor="ctr"/>
+          <a:lstStyle/>
+          <a:p>
+            <a:pPr algn="ctr"/>
+            <a:r>
+              <a:rPr lang="en-AU" sz="1600" dirty="0">
+                <a:solidFill>
+                  <a:schemeClr val="tx1"/>
+                </a:solidFill>
+              </a:rPr>
+              <a:t>Solenoid</a:t>
+            </a:r>
+          </a:p>
+        </p:txBody>
+      </p:sp>
+      <p:sp>
+        <p:nvSpPr>
+          <p:cNvPr id="18" name="Rectangle 17">
+            <a:extLst>
+              <a:ext uri="{FF2B5EF4-FFF2-40B4-BE49-F238E27FC236}">
+                <a16:creationId xmlns:a16="http://schemas.microsoft.com/office/drawing/2014/main" id="{A12E1264-6B4B-29E8-5C2F-DF6F4307BF49}"/>
+              </a:ext>
+            </a:extLst>
+          </p:cNvPr>
+          <p:cNvSpPr/>
+          <p:nvPr/>
+        </p:nvSpPr>
+        <p:spPr>
+          <a:xfrm>
+            <a:off x="2116666" y="355600"/>
+            <a:ext cx="1744134" cy="353512"/>
+          </a:xfrm>
+          <a:prstGeom prst="rect">
+            <a:avLst/>
+          </a:prstGeom>
+          <a:solidFill>
+            <a:schemeClr val="bg1"/>
+          </a:solidFill>
+          <a:ln>
+            <a:noFill/>
+          </a:ln>
+        </p:spPr>
+        <p:style>
+          <a:lnRef idx="2">
+            <a:schemeClr val="accent1">
+              <a:shade val="15000"/>
+            </a:schemeClr>
+          </a:lnRef>
+          <a:fillRef idx="1">
+            <a:schemeClr val="accent1"/>
+          </a:fillRef>
+          <a:effectRef idx="0">
+            <a:schemeClr val="accent1"/>
+          </a:effectRef>
+          <a:fontRef idx="minor">
+            <a:schemeClr val="lt1"/>
+          </a:fontRef>
+        </p:style>
+        <p:txBody>
+          <a:bodyPr rtlCol="0" anchor="ctr"/>
+          <a:lstStyle/>
+          <a:p>
+            <a:pPr algn="ctr"/>
+            <a:r>
+              <a:rPr lang="en-AU" dirty="0">
+                <a:solidFill>
+                  <a:srgbClr val="FF0000"/>
+                </a:solidFill>
+              </a:rPr>
+              <a:t>Coaxial cable</a:t>
+            </a:r>
+          </a:p>
+        </p:txBody>
+      </p:sp>
+      <p:sp>
+        <p:nvSpPr>
+          <p:cNvPr id="19" name="Rectangle 18">
+            <a:extLst>
+              <a:ext uri="{FF2B5EF4-FFF2-40B4-BE49-F238E27FC236}">
+                <a16:creationId xmlns:a16="http://schemas.microsoft.com/office/drawing/2014/main" id="{1137ABC9-41A4-9D8D-B4CB-3E9FE94C9868}"/>
+              </a:ext>
+            </a:extLst>
+          </p:cNvPr>
+          <p:cNvSpPr/>
+          <p:nvPr/>
+        </p:nvSpPr>
+        <p:spPr>
+          <a:xfrm>
+            <a:off x="1459832" y="926168"/>
+            <a:ext cx="1633175" cy="724831"/>
+          </a:xfrm>
+          <a:prstGeom prst="rect">
+            <a:avLst/>
+          </a:prstGeom>
+          <a:solidFill>
+            <a:srgbClr val="CCCCCC"/>
+          </a:solidFill>
+          <a:ln>
+            <a:noFill/>
+          </a:ln>
+        </p:spPr>
+        <p:style>
+          <a:lnRef idx="2">
+            <a:schemeClr val="accent1">
+              <a:shade val="15000"/>
+            </a:schemeClr>
+          </a:lnRef>
+          <a:fillRef idx="1">
+            <a:schemeClr val="accent1"/>
+          </a:fillRef>
+          <a:effectRef idx="0">
+            <a:schemeClr val="accent1"/>
+          </a:effectRef>
+          <a:fontRef idx="minor">
+            <a:schemeClr val="lt1"/>
+          </a:fontRef>
+        </p:style>
+        <p:txBody>
+          <a:bodyPr rtlCol="0" anchor="ctr"/>
+          <a:lstStyle/>
+          <a:p>
+            <a:pPr algn="ctr"/>
+            <a:r>
+              <a:rPr lang="en-AU" dirty="0">
+                <a:solidFill>
+                  <a:schemeClr val="tx1"/>
+                </a:solidFill>
+              </a:rPr>
+              <a:t>VNA</a:t>
+            </a:r>
+          </a:p>
+        </p:txBody>
+      </p:sp>
+      <p:sp>
+        <p:nvSpPr>
+          <p:cNvPr id="20" name="Rectangle 19">
+            <a:extLst>
+              <a:ext uri="{FF2B5EF4-FFF2-40B4-BE49-F238E27FC236}">
+                <a16:creationId xmlns:a16="http://schemas.microsoft.com/office/drawing/2014/main" id="{C1F6B408-81D6-6C37-ACAE-2256CB693A92}"/>
+              </a:ext>
+            </a:extLst>
+          </p:cNvPr>
+          <p:cNvSpPr/>
+          <p:nvPr/>
+        </p:nvSpPr>
+        <p:spPr>
+          <a:xfrm>
+            <a:off x="5486704" y="1146302"/>
+            <a:ext cx="745067" cy="724831"/>
+          </a:xfrm>
+          <a:prstGeom prst="rect">
+            <a:avLst/>
+          </a:prstGeom>
+          <a:solidFill>
+            <a:schemeClr val="bg1"/>
+          </a:solidFill>
+          <a:ln>
+            <a:noFill/>
+          </a:ln>
+        </p:spPr>
+        <p:style>
+          <a:lnRef idx="2">
+            <a:schemeClr val="accent1">
+              <a:shade val="15000"/>
+            </a:schemeClr>
+          </a:lnRef>
+          <a:fillRef idx="1">
+            <a:schemeClr val="accent1"/>
+          </a:fillRef>
+          <a:effectRef idx="0">
+            <a:schemeClr val="accent1"/>
+          </a:effectRef>
+          <a:fontRef idx="minor">
+            <a:schemeClr val="lt1"/>
+          </a:fontRef>
+        </p:style>
+        <p:txBody>
+          <a:bodyPr rtlCol="0" anchor="ctr"/>
+          <a:lstStyle/>
+          <a:p>
+            <a:pPr algn="ctr"/>
+            <a:endParaRPr lang="en-AU"/>
+          </a:p>
+        </p:txBody>
+      </p:sp>
+      <p:sp>
+        <p:nvSpPr>
+          <p:cNvPr id="21" name="Rectangle 20">
+            <a:extLst>
+              <a:ext uri="{FF2B5EF4-FFF2-40B4-BE49-F238E27FC236}">
+                <a16:creationId xmlns:a16="http://schemas.microsoft.com/office/drawing/2014/main" id="{DF2DD8C6-3C33-5774-1310-FD94694C44E5}"/>
+              </a:ext>
+            </a:extLst>
+          </p:cNvPr>
+          <p:cNvSpPr/>
+          <p:nvPr/>
+        </p:nvSpPr>
+        <p:spPr>
+          <a:xfrm>
+            <a:off x="941721" y="2227919"/>
+            <a:ext cx="1403545" cy="724831"/>
+          </a:xfrm>
+          <a:prstGeom prst="rect">
+            <a:avLst/>
+          </a:prstGeom>
+          <a:solidFill>
+            <a:schemeClr val="bg1"/>
+          </a:solidFill>
+          <a:ln>
+            <a:noFill/>
+          </a:ln>
+        </p:spPr>
+        <p:style>
+          <a:lnRef idx="2">
+            <a:schemeClr val="accent1">
+              <a:shade val="15000"/>
+            </a:schemeClr>
+          </a:lnRef>
+          <a:fillRef idx="1">
+            <a:schemeClr val="accent1"/>
+          </a:fillRef>
+          <a:effectRef idx="0">
+            <a:schemeClr val="accent1"/>
+          </a:effectRef>
+          <a:fontRef idx="minor">
+            <a:schemeClr val="lt1"/>
+          </a:fontRef>
+        </p:style>
+        <p:txBody>
+          <a:bodyPr rtlCol="0" anchor="ctr"/>
+          <a:lstStyle/>
+          <a:p>
+            <a:pPr algn="ctr"/>
+            <a:r>
+              <a:rPr lang="en-AU" dirty="0">
+                <a:solidFill>
+                  <a:schemeClr val="accent6">
+                    <a:lumMod val="50000"/>
+                  </a:schemeClr>
+                </a:solidFill>
+              </a:rPr>
+              <a:t>Coplanar waveguide (CPW)</a:t>
+            </a:r>
+          </a:p>
+        </p:txBody>
+      </p:sp>
+      <p:sp>
+        <p:nvSpPr>
+          <p:cNvPr id="22" name="Rectangle 21">
+            <a:extLst>
+              <a:ext uri="{FF2B5EF4-FFF2-40B4-BE49-F238E27FC236}">
+                <a16:creationId xmlns:a16="http://schemas.microsoft.com/office/drawing/2014/main" id="{9F825858-B3AD-A6FF-C360-160C1112C980}"/>
+              </a:ext>
+            </a:extLst>
+          </p:cNvPr>
+          <p:cNvSpPr/>
+          <p:nvPr/>
+        </p:nvSpPr>
+        <p:spPr>
+          <a:xfrm>
+            <a:off x="1087298" y="1737267"/>
+            <a:ext cx="1257968" cy="456672"/>
+          </a:xfrm>
+          <a:prstGeom prst="rect">
+            <a:avLst/>
+          </a:prstGeom>
+          <a:solidFill>
+            <a:schemeClr val="bg1"/>
+          </a:solidFill>
+          <a:ln>
+            <a:noFill/>
+          </a:ln>
+        </p:spPr>
+        <p:style>
+          <a:lnRef idx="2">
+            <a:schemeClr val="accent1">
+              <a:shade val="15000"/>
+            </a:schemeClr>
+          </a:lnRef>
+          <a:fillRef idx="1">
+            <a:schemeClr val="accent1"/>
+          </a:fillRef>
+          <a:effectRef idx="0">
+            <a:schemeClr val="accent1"/>
+          </a:effectRef>
+          <a:fontRef idx="minor">
+            <a:schemeClr val="lt1"/>
+          </a:fontRef>
+        </p:style>
+        <p:txBody>
+          <a:bodyPr rtlCol="0" anchor="ctr"/>
+          <a:lstStyle/>
+          <a:p>
+            <a:pPr algn="ctr"/>
+            <a:r>
+              <a:rPr lang="en-AU" dirty="0">
+                <a:solidFill>
+                  <a:schemeClr val="tx1"/>
+                </a:solidFill>
+              </a:rPr>
+              <a:t>Pole piece</a:t>
+            </a:r>
+          </a:p>
+        </p:txBody>
+      </p:sp>
+      <p:sp>
+        <p:nvSpPr>
+          <p:cNvPr id="23" name="Rectangle 22">
+            <a:extLst>
+              <a:ext uri="{FF2B5EF4-FFF2-40B4-BE49-F238E27FC236}">
+                <a16:creationId xmlns:a16="http://schemas.microsoft.com/office/drawing/2014/main" id="{33878841-C82B-E50F-0A9E-4D0C7FEF9573}"/>
+              </a:ext>
+            </a:extLst>
+          </p:cNvPr>
+          <p:cNvSpPr/>
+          <p:nvPr/>
+        </p:nvSpPr>
+        <p:spPr>
+          <a:xfrm>
+            <a:off x="740165" y="3330320"/>
+            <a:ext cx="1605101" cy="657480"/>
+          </a:xfrm>
+          <a:prstGeom prst="rect">
+            <a:avLst/>
+          </a:prstGeom>
+          <a:solidFill>
+            <a:schemeClr val="bg1"/>
+          </a:solidFill>
+          <a:ln>
+            <a:noFill/>
+          </a:ln>
+        </p:spPr>
+        <p:style>
+          <a:lnRef idx="2">
+            <a:schemeClr val="accent1">
+              <a:shade val="15000"/>
+            </a:schemeClr>
+          </a:lnRef>
+          <a:fillRef idx="1">
+            <a:schemeClr val="accent1"/>
+          </a:fillRef>
+          <a:effectRef idx="0">
+            <a:schemeClr val="accent1"/>
+          </a:effectRef>
+          <a:fontRef idx="minor">
+            <a:schemeClr val="lt1"/>
+          </a:fontRef>
+        </p:style>
+        <p:txBody>
+          <a:bodyPr rtlCol="0" anchor="ctr"/>
+          <a:lstStyle/>
+          <a:p>
+            <a:pPr algn="ctr"/>
+            <a:r>
+              <a:rPr lang="en-AU" dirty="0">
+                <a:solidFill>
+                  <a:srgbClr val="FF0000"/>
+                </a:solidFill>
+              </a:rPr>
+              <a:t>Modulation coil</a:t>
+            </a:r>
+          </a:p>
+        </p:txBody>
+      </p:sp>
+      <p:sp>
+        <p:nvSpPr>
+          <p:cNvPr id="25" name="Rectangle 24">
+            <a:extLst>
+              <a:ext uri="{FF2B5EF4-FFF2-40B4-BE49-F238E27FC236}">
+                <a16:creationId xmlns:a16="http://schemas.microsoft.com/office/drawing/2014/main" id="{1B895AE5-25C7-FDDF-9A82-D1DFD3E671D2}"/>
+              </a:ext>
+            </a:extLst>
+          </p:cNvPr>
+          <p:cNvSpPr/>
+          <p:nvPr/>
+        </p:nvSpPr>
+        <p:spPr>
+          <a:xfrm>
+            <a:off x="8654717" y="1566182"/>
+            <a:ext cx="506216" cy="304951"/>
+          </a:xfrm>
+          <a:prstGeom prst="rect">
+            <a:avLst/>
+          </a:prstGeom>
+          <a:solidFill>
+            <a:srgbClr val="CCCCCC"/>
+          </a:solidFill>
+          <a:ln>
+            <a:noFill/>
+          </a:ln>
+        </p:spPr>
+        <p:style>
+          <a:lnRef idx="2">
+            <a:schemeClr val="accent1">
+              <a:shade val="15000"/>
+            </a:schemeClr>
+          </a:lnRef>
+          <a:fillRef idx="1">
+            <a:schemeClr val="accent1"/>
+          </a:fillRef>
+          <a:effectRef idx="0">
+            <a:schemeClr val="accent1"/>
+          </a:effectRef>
+          <a:fontRef idx="minor">
+            <a:schemeClr val="lt1"/>
+          </a:fontRef>
+        </p:style>
+        <p:txBody>
+          <a:bodyPr rtlCol="0" anchor="ctr"/>
+          <a:lstStyle/>
+          <a:p>
+            <a:pPr algn="ctr"/>
+            <a:r>
+              <a:rPr lang="en-AU" dirty="0">
+                <a:solidFill>
+                  <a:schemeClr val="tx1"/>
+                </a:solidFill>
+              </a:rPr>
+              <a:t>In</a:t>
+            </a:r>
+          </a:p>
+        </p:txBody>
+      </p:sp>
+      <p:sp>
+        <p:nvSpPr>
+          <p:cNvPr id="27" name="Rectangle 26">
+            <a:extLst>
+              <a:ext uri="{FF2B5EF4-FFF2-40B4-BE49-F238E27FC236}">
+                <a16:creationId xmlns:a16="http://schemas.microsoft.com/office/drawing/2014/main" id="{860FE2EF-7FA9-F06F-B818-FAECFD80BC2D}"/>
+              </a:ext>
+            </a:extLst>
+          </p:cNvPr>
+          <p:cNvSpPr/>
+          <p:nvPr/>
+        </p:nvSpPr>
+        <p:spPr>
+          <a:xfrm>
+            <a:off x="9160932" y="2690989"/>
+            <a:ext cx="887721" cy="304951"/>
+          </a:xfrm>
+          <a:prstGeom prst="rect">
+            <a:avLst/>
+          </a:prstGeom>
+          <a:solidFill>
+            <a:srgbClr val="CCCCCC"/>
+          </a:solidFill>
+          <a:ln>
+            <a:noFill/>
+          </a:ln>
+        </p:spPr>
+        <p:style>
+          <a:lnRef idx="2">
+            <a:schemeClr val="accent1">
+              <a:shade val="15000"/>
+            </a:schemeClr>
+          </a:lnRef>
+          <a:fillRef idx="1">
+            <a:schemeClr val="accent1"/>
+          </a:fillRef>
+          <a:effectRef idx="0">
+            <a:schemeClr val="accent1"/>
+          </a:effectRef>
+          <a:fontRef idx="minor">
+            <a:schemeClr val="lt1"/>
+          </a:fontRef>
+        </p:style>
+        <p:txBody>
+          <a:bodyPr rtlCol="0" anchor="ctr"/>
+          <a:lstStyle/>
+          <a:p>
+            <a:pPr algn="ctr"/>
+            <a:r>
+              <a:rPr lang="en-AU" dirty="0">
+                <a:solidFill>
+                  <a:schemeClr val="tx1"/>
+                </a:solidFill>
+              </a:rPr>
+              <a:t>Ref out</a:t>
+            </a:r>
+          </a:p>
+        </p:txBody>
+      </p:sp>
+      <p:sp>
+        <p:nvSpPr>
+          <p:cNvPr id="28" name="Rectangle 27">
+            <a:extLst>
+              <a:ext uri="{FF2B5EF4-FFF2-40B4-BE49-F238E27FC236}">
+                <a16:creationId xmlns:a16="http://schemas.microsoft.com/office/drawing/2014/main" id="{DCD2FE95-9681-1D5A-EB73-C4F9E92120C4}"/>
+              </a:ext>
+            </a:extLst>
+          </p:cNvPr>
+          <p:cNvSpPr/>
+          <p:nvPr/>
+        </p:nvSpPr>
+        <p:spPr>
+          <a:xfrm>
+            <a:off x="8823006" y="1895373"/>
+            <a:ext cx="1403544" cy="724831"/>
+          </a:xfrm>
+          <a:prstGeom prst="rect">
+            <a:avLst/>
+          </a:prstGeom>
+          <a:solidFill>
+            <a:srgbClr val="CCCCCC"/>
+          </a:solidFill>
+          <a:ln>
+            <a:noFill/>
+          </a:ln>
+        </p:spPr>
+        <p:style>
+          <a:lnRef idx="2">
+            <a:schemeClr val="accent1">
+              <a:shade val="15000"/>
+            </a:schemeClr>
+          </a:lnRef>
+          <a:fillRef idx="1">
+            <a:schemeClr val="accent1"/>
+          </a:fillRef>
+          <a:effectRef idx="0">
+            <a:schemeClr val="accent1"/>
+          </a:effectRef>
+          <a:fontRef idx="minor">
+            <a:schemeClr val="lt1"/>
+          </a:fontRef>
+        </p:style>
+        <p:txBody>
+          <a:bodyPr rtlCol="0" anchor="ctr"/>
+          <a:lstStyle/>
+          <a:p>
+            <a:pPr algn="ctr"/>
+            <a:r>
+              <a:rPr lang="en-AU" dirty="0">
+                <a:solidFill>
+                  <a:schemeClr val="tx1"/>
+                </a:solidFill>
+              </a:rPr>
+              <a:t>Lock-in Amplifier</a:t>
+            </a:r>
+          </a:p>
+        </p:txBody>
+      </p:sp>
+      <p:sp>
+        <p:nvSpPr>
+          <p:cNvPr id="29" name="Rectangle 28">
+            <a:extLst>
+              <a:ext uri="{FF2B5EF4-FFF2-40B4-BE49-F238E27FC236}">
+                <a16:creationId xmlns:a16="http://schemas.microsoft.com/office/drawing/2014/main" id="{8DE41CB9-A5EC-B57C-19F9-5E391EA0776F}"/>
+              </a:ext>
+            </a:extLst>
+          </p:cNvPr>
+          <p:cNvSpPr/>
+          <p:nvPr/>
+        </p:nvSpPr>
+        <p:spPr>
+          <a:xfrm>
+            <a:off x="9822670" y="1584791"/>
+            <a:ext cx="548551" cy="304951"/>
+          </a:xfrm>
+          <a:prstGeom prst="rect">
+            <a:avLst/>
+          </a:prstGeom>
+          <a:solidFill>
+            <a:srgbClr val="CCCCCC"/>
+          </a:solidFill>
+          <a:ln>
+            <a:noFill/>
+          </a:ln>
+        </p:spPr>
+        <p:style>
+          <a:lnRef idx="2">
+            <a:schemeClr val="accent1">
+              <a:shade val="15000"/>
+            </a:schemeClr>
+          </a:lnRef>
+          <a:fillRef idx="1">
+            <a:schemeClr val="accent1"/>
+          </a:fillRef>
+          <a:effectRef idx="0">
+            <a:schemeClr val="accent1"/>
+          </a:effectRef>
+          <a:fontRef idx="minor">
+            <a:schemeClr val="lt1"/>
+          </a:fontRef>
+        </p:style>
+        <p:txBody>
+          <a:bodyPr rtlCol="0" anchor="ctr"/>
+          <a:lstStyle/>
+          <a:p>
+            <a:pPr algn="ctr"/>
+            <a:r>
+              <a:rPr lang="en-AU" dirty="0">
+                <a:solidFill>
+                  <a:schemeClr val="tx1"/>
+                </a:solidFill>
+              </a:rPr>
+              <a:t>Out</a:t>
+            </a:r>
+          </a:p>
+        </p:txBody>
+      </p:sp>
+      <p:sp>
+        <p:nvSpPr>
+          <p:cNvPr id="30" name="Rectangle 29">
+            <a:extLst>
+              <a:ext uri="{FF2B5EF4-FFF2-40B4-BE49-F238E27FC236}">
+                <a16:creationId xmlns:a16="http://schemas.microsoft.com/office/drawing/2014/main" id="{4429B36A-D763-43B5-8AE2-53A933F66CFD}"/>
+              </a:ext>
+            </a:extLst>
+          </p:cNvPr>
+          <p:cNvSpPr/>
+          <p:nvPr/>
+        </p:nvSpPr>
+        <p:spPr>
+          <a:xfrm>
+            <a:off x="4538438" y="3301935"/>
+            <a:ext cx="948266" cy="254129"/>
+          </a:xfrm>
+          <a:prstGeom prst="rect">
+            <a:avLst/>
+          </a:prstGeom>
+          <a:solidFill>
+            <a:schemeClr val="bg1"/>
+          </a:solidFill>
+          <a:ln>
+            <a:noFill/>
+          </a:ln>
+        </p:spPr>
+        <p:style>
+          <a:lnRef idx="2">
+            <a:schemeClr val="accent1">
+              <a:shade val="15000"/>
+            </a:schemeClr>
+          </a:lnRef>
+          <a:fillRef idx="1">
+            <a:schemeClr val="accent1"/>
+          </a:fillRef>
+          <a:effectRef idx="0">
+            <a:schemeClr val="accent1"/>
+          </a:effectRef>
+          <a:fontRef idx="minor">
+            <a:schemeClr val="lt1"/>
+          </a:fontRef>
+        </p:style>
+        <p:txBody>
+          <a:bodyPr rtlCol="0" anchor="ctr"/>
+          <a:lstStyle/>
+          <a:p>
+            <a:pPr algn="ctr"/>
+            <a:r>
+              <a:rPr lang="en-AU" dirty="0">
+                <a:solidFill>
+                  <a:srgbClr val="0666CC"/>
+                </a:solidFill>
+              </a:rPr>
+              <a:t>Sample</a:t>
+            </a:r>
+          </a:p>
+        </p:txBody>
+      </p:sp>
+      <p:sp>
+        <p:nvSpPr>
+          <p:cNvPr id="31" name="Rectangle 30">
+            <a:extLst>
+              <a:ext uri="{FF2B5EF4-FFF2-40B4-BE49-F238E27FC236}">
+                <a16:creationId xmlns:a16="http://schemas.microsoft.com/office/drawing/2014/main" id="{C613C86F-1AA2-39C2-7C62-57578BC9A124}"/>
+              </a:ext>
+            </a:extLst>
+          </p:cNvPr>
+          <p:cNvSpPr/>
+          <p:nvPr/>
+        </p:nvSpPr>
+        <p:spPr>
+          <a:xfrm>
+            <a:off x="7002238" y="693251"/>
+            <a:ext cx="1125762" cy="724831"/>
+          </a:xfrm>
+          <a:prstGeom prst="rect">
+            <a:avLst/>
+          </a:prstGeom>
+          <a:solidFill>
+            <a:srgbClr val="CCCCCC"/>
+          </a:solidFill>
+          <a:ln>
+            <a:noFill/>
+          </a:ln>
+        </p:spPr>
+        <p:style>
+          <a:lnRef idx="2">
+            <a:schemeClr val="accent1">
+              <a:shade val="15000"/>
+            </a:schemeClr>
+          </a:lnRef>
+          <a:fillRef idx="1">
+            <a:schemeClr val="accent1"/>
+          </a:fillRef>
+          <a:effectRef idx="0">
+            <a:schemeClr val="accent1"/>
+          </a:effectRef>
+          <a:fontRef idx="minor">
+            <a:schemeClr val="lt1"/>
+          </a:fontRef>
+        </p:style>
+        <p:txBody>
+          <a:bodyPr rtlCol="0" anchor="ctr"/>
+          <a:lstStyle/>
+          <a:p>
+            <a:pPr algn="ctr"/>
+            <a:r>
+              <a:rPr lang="en-AU" dirty="0">
+                <a:solidFill>
+                  <a:schemeClr val="tx1"/>
+                </a:solidFill>
+              </a:rPr>
+              <a:t>Gauss Meter</a:t>
+            </a:r>
+          </a:p>
+        </p:txBody>
+      </p:sp>
+      <p:sp>
+        <p:nvSpPr>
+          <p:cNvPr id="32" name="Rectangle 31">
+            <a:extLst>
+              <a:ext uri="{FF2B5EF4-FFF2-40B4-BE49-F238E27FC236}">
+                <a16:creationId xmlns:a16="http://schemas.microsoft.com/office/drawing/2014/main" id="{485C7E9D-9380-8EAF-6E4A-A68C13F286A8}"/>
+              </a:ext>
+            </a:extLst>
+          </p:cNvPr>
+          <p:cNvSpPr/>
+          <p:nvPr/>
+        </p:nvSpPr>
+        <p:spPr>
+          <a:xfrm>
+            <a:off x="9050726" y="421471"/>
+            <a:ext cx="1320495" cy="724831"/>
+          </a:xfrm>
+          <a:prstGeom prst="rect">
+            <a:avLst/>
+          </a:prstGeom>
+          <a:solidFill>
+            <a:schemeClr val="bg1"/>
+          </a:solidFill>
+          <a:ln>
+            <a:noFill/>
+          </a:ln>
+        </p:spPr>
+        <p:style>
+          <a:lnRef idx="2">
+            <a:schemeClr val="accent1">
+              <a:shade val="15000"/>
+            </a:schemeClr>
+          </a:lnRef>
+          <a:fillRef idx="1">
+            <a:schemeClr val="accent1"/>
+          </a:fillRef>
+          <a:effectRef idx="0">
+            <a:schemeClr val="accent1"/>
+          </a:effectRef>
+          <a:fontRef idx="minor">
+            <a:schemeClr val="lt1"/>
+          </a:fontRef>
+        </p:style>
+        <p:txBody>
+          <a:bodyPr rtlCol="0" anchor="ctr"/>
+          <a:lstStyle/>
+          <a:p>
+            <a:pPr algn="ctr"/>
+            <a:r>
+              <a:rPr lang="en-AU" dirty="0">
+                <a:solidFill>
+                  <a:schemeClr val="tx1"/>
+                </a:solidFill>
+              </a:rPr>
+              <a:t>Schottky diode</a:t>
+            </a:r>
+          </a:p>
+        </p:txBody>
+      </p:sp>
+      <p:sp>
+        <p:nvSpPr>
+          <p:cNvPr id="2" name="Rectangle 1">
+            <a:extLst>
+              <a:ext uri="{FF2B5EF4-FFF2-40B4-BE49-F238E27FC236}">
+                <a16:creationId xmlns:a16="http://schemas.microsoft.com/office/drawing/2014/main" id="{00F9B81F-030F-3DED-AB84-83F649CB92CE}"/>
+              </a:ext>
+            </a:extLst>
+          </p:cNvPr>
+          <p:cNvSpPr/>
+          <p:nvPr/>
+        </p:nvSpPr>
+        <p:spPr>
+          <a:xfrm>
+            <a:off x="5788550" y="2667781"/>
+            <a:ext cx="958410" cy="351366"/>
+          </a:xfrm>
+          <a:prstGeom prst="rect">
+            <a:avLst/>
+          </a:prstGeom>
+          <a:solidFill>
+            <a:srgbClr val="94BD5E"/>
+          </a:solidFill>
+          <a:ln>
+            <a:noFill/>
+          </a:ln>
+        </p:spPr>
+        <p:style>
+          <a:lnRef idx="2">
+            <a:schemeClr val="accent1">
+              <a:shade val="15000"/>
+            </a:schemeClr>
+          </a:lnRef>
+          <a:fillRef idx="1">
+            <a:schemeClr val="accent1"/>
+          </a:fillRef>
+          <a:effectRef idx="0">
+            <a:schemeClr val="accent1"/>
+          </a:effectRef>
+          <a:fontRef idx="minor">
+            <a:schemeClr val="lt1"/>
+          </a:fontRef>
+        </p:style>
+        <p:txBody>
+          <a:bodyPr rtlCol="0" anchor="ctr"/>
+          <a:lstStyle/>
+          <a:p>
+            <a:pPr algn="ctr"/>
+            <a:r>
+              <a:rPr lang="en-AU" sz="1600" dirty="0">
+                <a:solidFill>
+                  <a:schemeClr val="tx1"/>
+                </a:solidFill>
+              </a:rPr>
+              <a:t>Solenoid</a:t>
+            </a:r>
+          </a:p>
+        </p:txBody>
+      </p:sp>
+      <p:sp>
+        <p:nvSpPr>
+          <p:cNvPr id="16" name="Freeform: Shape 15">
+            <a:extLst>
+              <a:ext uri="{FF2B5EF4-FFF2-40B4-BE49-F238E27FC236}">
+                <a16:creationId xmlns:a16="http://schemas.microsoft.com/office/drawing/2014/main" id="{68B91B7E-2E2F-FDEC-3CD5-1B0F4BC52A01}"/>
+              </a:ext>
+            </a:extLst>
+          </p:cNvPr>
+          <p:cNvSpPr/>
+          <p:nvPr/>
+        </p:nvSpPr>
+        <p:spPr>
+          <a:xfrm>
+            <a:off x="3959921" y="2945130"/>
+            <a:ext cx="143848" cy="45719"/>
           </a:xfrm>
           <a:custGeom>
             <a:avLst/>
@@ -4370,828 +5250,7 @@
           <a:lstStyle/>
           <a:p>
             <a:pPr algn="ctr"/>
-            <a:endParaRPr lang="en-AU"/>
-          </a:p>
-        </p:txBody>
-      </p:sp>
-      <p:sp>
-        <p:nvSpPr>
-          <p:cNvPr id="17" name="Rectangle 16">
-            <a:extLst>
-              <a:ext uri="{FF2B5EF4-FFF2-40B4-BE49-F238E27FC236}">
-                <a16:creationId xmlns:a16="http://schemas.microsoft.com/office/drawing/2014/main" id="{74DEB147-FDB5-25EF-B5BA-A97A1AFF8B86}"/>
-              </a:ext>
-            </a:extLst>
-          </p:cNvPr>
-          <p:cNvSpPr/>
-          <p:nvPr/>
-        </p:nvSpPr>
-        <p:spPr>
-          <a:xfrm>
-            <a:off x="5859238" y="2650143"/>
-            <a:ext cx="887722" cy="351366"/>
-          </a:xfrm>
-          <a:prstGeom prst="rect">
-            <a:avLst/>
-          </a:prstGeom>
-          <a:solidFill>
-            <a:srgbClr val="94BD5E"/>
-          </a:solidFill>
-          <a:ln>
-            <a:noFill/>
-          </a:ln>
-        </p:spPr>
-        <p:style>
-          <a:lnRef idx="2">
-            <a:schemeClr val="accent1">
-              <a:shade val="15000"/>
-            </a:schemeClr>
-          </a:lnRef>
-          <a:fillRef idx="1">
-            <a:schemeClr val="accent1"/>
-          </a:fillRef>
-          <a:effectRef idx="0">
-            <a:schemeClr val="accent1"/>
-          </a:effectRef>
-          <a:fontRef idx="minor">
-            <a:schemeClr val="lt1"/>
-          </a:fontRef>
-        </p:style>
-        <p:txBody>
-          <a:bodyPr rtlCol="0" anchor="ctr"/>
-          <a:lstStyle/>
-          <a:p>
-            <a:pPr algn="ctr"/>
-            <a:r>
-              <a:rPr lang="en-AU" dirty="0">
-                <a:solidFill>
-                  <a:schemeClr val="tx1"/>
-                </a:solidFill>
-              </a:rPr>
-              <a:t>Coil</a:t>
-            </a:r>
-          </a:p>
-        </p:txBody>
-      </p:sp>
-      <p:sp>
-        <p:nvSpPr>
-          <p:cNvPr id="18" name="Rectangle 17">
-            <a:extLst>
-              <a:ext uri="{FF2B5EF4-FFF2-40B4-BE49-F238E27FC236}">
-                <a16:creationId xmlns:a16="http://schemas.microsoft.com/office/drawing/2014/main" id="{A12E1264-6B4B-29E8-5C2F-DF6F4307BF49}"/>
-              </a:ext>
-            </a:extLst>
-          </p:cNvPr>
-          <p:cNvSpPr/>
-          <p:nvPr/>
-        </p:nvSpPr>
-        <p:spPr>
-          <a:xfrm>
-            <a:off x="2116666" y="355600"/>
-            <a:ext cx="1744134" cy="353512"/>
-          </a:xfrm>
-          <a:prstGeom prst="rect">
-            <a:avLst/>
-          </a:prstGeom>
-          <a:solidFill>
-            <a:schemeClr val="bg1"/>
-          </a:solidFill>
-          <a:ln>
-            <a:noFill/>
-          </a:ln>
-        </p:spPr>
-        <p:style>
-          <a:lnRef idx="2">
-            <a:schemeClr val="accent1">
-              <a:shade val="15000"/>
-            </a:schemeClr>
-          </a:lnRef>
-          <a:fillRef idx="1">
-            <a:schemeClr val="accent1"/>
-          </a:fillRef>
-          <a:effectRef idx="0">
-            <a:schemeClr val="accent1"/>
-          </a:effectRef>
-          <a:fontRef idx="minor">
-            <a:schemeClr val="lt1"/>
-          </a:fontRef>
-        </p:style>
-        <p:txBody>
-          <a:bodyPr rtlCol="0" anchor="ctr"/>
-          <a:lstStyle/>
-          <a:p>
-            <a:pPr algn="ctr"/>
-            <a:r>
-              <a:rPr lang="en-AU" dirty="0">
-                <a:solidFill>
-                  <a:srgbClr val="FF0000"/>
-                </a:solidFill>
-              </a:rPr>
-              <a:t>Coaxial cable</a:t>
-            </a:r>
-          </a:p>
-        </p:txBody>
-      </p:sp>
-      <p:sp>
-        <p:nvSpPr>
-          <p:cNvPr id="19" name="Rectangle 18">
-            <a:extLst>
-              <a:ext uri="{FF2B5EF4-FFF2-40B4-BE49-F238E27FC236}">
-                <a16:creationId xmlns:a16="http://schemas.microsoft.com/office/drawing/2014/main" id="{1137ABC9-41A4-9D8D-B4CB-3E9FE94C9868}"/>
-              </a:ext>
-            </a:extLst>
-          </p:cNvPr>
-          <p:cNvSpPr/>
-          <p:nvPr/>
-        </p:nvSpPr>
-        <p:spPr>
-          <a:xfrm>
-            <a:off x="1459832" y="926168"/>
-            <a:ext cx="1633175" cy="724831"/>
-          </a:xfrm>
-          <a:prstGeom prst="rect">
-            <a:avLst/>
-          </a:prstGeom>
-          <a:solidFill>
-            <a:srgbClr val="CCCCCC"/>
-          </a:solidFill>
-          <a:ln>
-            <a:noFill/>
-          </a:ln>
-        </p:spPr>
-        <p:style>
-          <a:lnRef idx="2">
-            <a:schemeClr val="accent1">
-              <a:shade val="15000"/>
-            </a:schemeClr>
-          </a:lnRef>
-          <a:fillRef idx="1">
-            <a:schemeClr val="accent1"/>
-          </a:fillRef>
-          <a:effectRef idx="0">
-            <a:schemeClr val="accent1"/>
-          </a:effectRef>
-          <a:fontRef idx="minor">
-            <a:schemeClr val="lt1"/>
-          </a:fontRef>
-        </p:style>
-        <p:txBody>
-          <a:bodyPr rtlCol="0" anchor="ctr"/>
-          <a:lstStyle/>
-          <a:p>
-            <a:pPr algn="ctr"/>
-            <a:r>
-              <a:rPr lang="en-AU" dirty="0">
-                <a:solidFill>
-                  <a:schemeClr val="tx1"/>
-                </a:solidFill>
-              </a:rPr>
-              <a:t>VNA</a:t>
-            </a:r>
-          </a:p>
-        </p:txBody>
-      </p:sp>
-      <p:sp>
-        <p:nvSpPr>
-          <p:cNvPr id="20" name="Rectangle 19">
-            <a:extLst>
-              <a:ext uri="{FF2B5EF4-FFF2-40B4-BE49-F238E27FC236}">
-                <a16:creationId xmlns:a16="http://schemas.microsoft.com/office/drawing/2014/main" id="{C1F6B408-81D6-6C37-ACAE-2256CB693A92}"/>
-              </a:ext>
-            </a:extLst>
-          </p:cNvPr>
-          <p:cNvSpPr/>
-          <p:nvPr/>
-        </p:nvSpPr>
-        <p:spPr>
-          <a:xfrm>
-            <a:off x="5486704" y="1146302"/>
-            <a:ext cx="745067" cy="724831"/>
-          </a:xfrm>
-          <a:prstGeom prst="rect">
-            <a:avLst/>
-          </a:prstGeom>
-          <a:solidFill>
-            <a:schemeClr val="bg1"/>
-          </a:solidFill>
-          <a:ln>
-            <a:noFill/>
-          </a:ln>
-        </p:spPr>
-        <p:style>
-          <a:lnRef idx="2">
-            <a:schemeClr val="accent1">
-              <a:shade val="15000"/>
-            </a:schemeClr>
-          </a:lnRef>
-          <a:fillRef idx="1">
-            <a:schemeClr val="accent1"/>
-          </a:fillRef>
-          <a:effectRef idx="0">
-            <a:schemeClr val="accent1"/>
-          </a:effectRef>
-          <a:fontRef idx="minor">
-            <a:schemeClr val="lt1"/>
-          </a:fontRef>
-        </p:style>
-        <p:txBody>
-          <a:bodyPr rtlCol="0" anchor="ctr"/>
-          <a:lstStyle/>
-          <a:p>
-            <a:pPr algn="ctr"/>
-            <a:endParaRPr lang="en-AU"/>
-          </a:p>
-        </p:txBody>
-      </p:sp>
-      <p:sp>
-        <p:nvSpPr>
-          <p:cNvPr id="21" name="Rectangle 20">
-            <a:extLst>
-              <a:ext uri="{FF2B5EF4-FFF2-40B4-BE49-F238E27FC236}">
-                <a16:creationId xmlns:a16="http://schemas.microsoft.com/office/drawing/2014/main" id="{DF2DD8C6-3C33-5774-1310-FD94694C44E5}"/>
-              </a:ext>
-            </a:extLst>
-          </p:cNvPr>
-          <p:cNvSpPr/>
-          <p:nvPr/>
-        </p:nvSpPr>
-        <p:spPr>
-          <a:xfrm>
-            <a:off x="941721" y="2227919"/>
-            <a:ext cx="1403545" cy="724831"/>
-          </a:xfrm>
-          <a:prstGeom prst="rect">
-            <a:avLst/>
-          </a:prstGeom>
-          <a:solidFill>
-            <a:schemeClr val="bg1"/>
-          </a:solidFill>
-          <a:ln>
-            <a:noFill/>
-          </a:ln>
-        </p:spPr>
-        <p:style>
-          <a:lnRef idx="2">
-            <a:schemeClr val="accent1">
-              <a:shade val="15000"/>
-            </a:schemeClr>
-          </a:lnRef>
-          <a:fillRef idx="1">
-            <a:schemeClr val="accent1"/>
-          </a:fillRef>
-          <a:effectRef idx="0">
-            <a:schemeClr val="accent1"/>
-          </a:effectRef>
-          <a:fontRef idx="minor">
-            <a:schemeClr val="lt1"/>
-          </a:fontRef>
-        </p:style>
-        <p:txBody>
-          <a:bodyPr rtlCol="0" anchor="ctr"/>
-          <a:lstStyle/>
-          <a:p>
-            <a:pPr algn="ctr"/>
-            <a:r>
-              <a:rPr lang="en-AU" dirty="0">
-                <a:solidFill>
-                  <a:schemeClr val="accent6">
-                    <a:lumMod val="50000"/>
-                  </a:schemeClr>
-                </a:solidFill>
-              </a:rPr>
-              <a:t>Coplanar waveguide (CPW)</a:t>
-            </a:r>
-          </a:p>
-        </p:txBody>
-      </p:sp>
-      <p:sp>
-        <p:nvSpPr>
-          <p:cNvPr id="22" name="Rectangle 21">
-            <a:extLst>
-              <a:ext uri="{FF2B5EF4-FFF2-40B4-BE49-F238E27FC236}">
-                <a16:creationId xmlns:a16="http://schemas.microsoft.com/office/drawing/2014/main" id="{9F825858-B3AD-A6FF-C360-160C1112C980}"/>
-              </a:ext>
-            </a:extLst>
-          </p:cNvPr>
-          <p:cNvSpPr/>
-          <p:nvPr/>
-        </p:nvSpPr>
-        <p:spPr>
-          <a:xfrm>
-            <a:off x="1087298" y="1737267"/>
-            <a:ext cx="1257968" cy="456672"/>
-          </a:xfrm>
-          <a:prstGeom prst="rect">
-            <a:avLst/>
-          </a:prstGeom>
-          <a:solidFill>
-            <a:schemeClr val="bg1"/>
-          </a:solidFill>
-          <a:ln>
-            <a:noFill/>
-          </a:ln>
-        </p:spPr>
-        <p:style>
-          <a:lnRef idx="2">
-            <a:schemeClr val="accent1">
-              <a:shade val="15000"/>
-            </a:schemeClr>
-          </a:lnRef>
-          <a:fillRef idx="1">
-            <a:schemeClr val="accent1"/>
-          </a:fillRef>
-          <a:effectRef idx="0">
-            <a:schemeClr val="accent1"/>
-          </a:effectRef>
-          <a:fontRef idx="minor">
-            <a:schemeClr val="lt1"/>
-          </a:fontRef>
-        </p:style>
-        <p:txBody>
-          <a:bodyPr rtlCol="0" anchor="ctr"/>
-          <a:lstStyle/>
-          <a:p>
-            <a:pPr algn="ctr"/>
-            <a:r>
-              <a:rPr lang="en-AU" dirty="0">
-                <a:solidFill>
-                  <a:schemeClr val="tx1"/>
-                </a:solidFill>
-              </a:rPr>
-              <a:t>Pole piece</a:t>
-            </a:r>
-          </a:p>
-        </p:txBody>
-      </p:sp>
-      <p:sp>
-        <p:nvSpPr>
-          <p:cNvPr id="23" name="Rectangle 22">
-            <a:extLst>
-              <a:ext uri="{FF2B5EF4-FFF2-40B4-BE49-F238E27FC236}">
-                <a16:creationId xmlns:a16="http://schemas.microsoft.com/office/drawing/2014/main" id="{33878841-C82B-E50F-0A9E-4D0C7FEF9573}"/>
-              </a:ext>
-            </a:extLst>
-          </p:cNvPr>
-          <p:cNvSpPr/>
-          <p:nvPr/>
-        </p:nvSpPr>
-        <p:spPr>
-          <a:xfrm>
-            <a:off x="740165" y="3330320"/>
-            <a:ext cx="1605101" cy="657480"/>
-          </a:xfrm>
-          <a:prstGeom prst="rect">
-            <a:avLst/>
-          </a:prstGeom>
-          <a:solidFill>
-            <a:schemeClr val="bg1"/>
-          </a:solidFill>
-          <a:ln>
-            <a:noFill/>
-          </a:ln>
-        </p:spPr>
-        <p:style>
-          <a:lnRef idx="2">
-            <a:schemeClr val="accent1">
-              <a:shade val="15000"/>
-            </a:schemeClr>
-          </a:lnRef>
-          <a:fillRef idx="1">
-            <a:schemeClr val="accent1"/>
-          </a:fillRef>
-          <a:effectRef idx="0">
-            <a:schemeClr val="accent1"/>
-          </a:effectRef>
-          <a:fontRef idx="minor">
-            <a:schemeClr val="lt1"/>
-          </a:fontRef>
-        </p:style>
-        <p:txBody>
-          <a:bodyPr rtlCol="0" anchor="ctr"/>
-          <a:lstStyle/>
-          <a:p>
-            <a:pPr algn="ctr"/>
-            <a:r>
-              <a:rPr lang="en-AU" dirty="0">
-                <a:solidFill>
-                  <a:srgbClr val="FF0000"/>
-                </a:solidFill>
-              </a:rPr>
-              <a:t>Modulation coil</a:t>
-            </a:r>
-          </a:p>
-        </p:txBody>
-      </p:sp>
-      <p:sp>
-        <p:nvSpPr>
-          <p:cNvPr id="25" name="Rectangle 24">
-            <a:extLst>
-              <a:ext uri="{FF2B5EF4-FFF2-40B4-BE49-F238E27FC236}">
-                <a16:creationId xmlns:a16="http://schemas.microsoft.com/office/drawing/2014/main" id="{1B895AE5-25C7-FDDF-9A82-D1DFD3E671D2}"/>
-              </a:ext>
-            </a:extLst>
-          </p:cNvPr>
-          <p:cNvSpPr/>
-          <p:nvPr/>
-        </p:nvSpPr>
-        <p:spPr>
-          <a:xfrm>
-            <a:off x="8654717" y="1566182"/>
-            <a:ext cx="506216" cy="304951"/>
-          </a:xfrm>
-          <a:prstGeom prst="rect">
-            <a:avLst/>
-          </a:prstGeom>
-          <a:solidFill>
-            <a:srgbClr val="CCCCCC"/>
-          </a:solidFill>
-          <a:ln>
-            <a:noFill/>
-          </a:ln>
-        </p:spPr>
-        <p:style>
-          <a:lnRef idx="2">
-            <a:schemeClr val="accent1">
-              <a:shade val="15000"/>
-            </a:schemeClr>
-          </a:lnRef>
-          <a:fillRef idx="1">
-            <a:schemeClr val="accent1"/>
-          </a:fillRef>
-          <a:effectRef idx="0">
-            <a:schemeClr val="accent1"/>
-          </a:effectRef>
-          <a:fontRef idx="minor">
-            <a:schemeClr val="lt1"/>
-          </a:fontRef>
-        </p:style>
-        <p:txBody>
-          <a:bodyPr rtlCol="0" anchor="ctr"/>
-          <a:lstStyle/>
-          <a:p>
-            <a:pPr algn="ctr"/>
-            <a:r>
-              <a:rPr lang="en-AU" dirty="0">
-                <a:solidFill>
-                  <a:schemeClr val="tx1"/>
-                </a:solidFill>
-              </a:rPr>
-              <a:t>In</a:t>
-            </a:r>
-          </a:p>
-        </p:txBody>
-      </p:sp>
-      <p:sp>
-        <p:nvSpPr>
-          <p:cNvPr id="27" name="Rectangle 26">
-            <a:extLst>
-              <a:ext uri="{FF2B5EF4-FFF2-40B4-BE49-F238E27FC236}">
-                <a16:creationId xmlns:a16="http://schemas.microsoft.com/office/drawing/2014/main" id="{860FE2EF-7FA9-F06F-B818-FAECFD80BC2D}"/>
-              </a:ext>
-            </a:extLst>
-          </p:cNvPr>
-          <p:cNvSpPr/>
-          <p:nvPr/>
-        </p:nvSpPr>
-        <p:spPr>
-          <a:xfrm>
-            <a:off x="9160932" y="2690989"/>
-            <a:ext cx="887721" cy="304951"/>
-          </a:xfrm>
-          <a:prstGeom prst="rect">
-            <a:avLst/>
-          </a:prstGeom>
-          <a:solidFill>
-            <a:srgbClr val="CCCCCC"/>
-          </a:solidFill>
-          <a:ln>
-            <a:noFill/>
-          </a:ln>
-        </p:spPr>
-        <p:style>
-          <a:lnRef idx="2">
-            <a:schemeClr val="accent1">
-              <a:shade val="15000"/>
-            </a:schemeClr>
-          </a:lnRef>
-          <a:fillRef idx="1">
-            <a:schemeClr val="accent1"/>
-          </a:fillRef>
-          <a:effectRef idx="0">
-            <a:schemeClr val="accent1"/>
-          </a:effectRef>
-          <a:fontRef idx="minor">
-            <a:schemeClr val="lt1"/>
-          </a:fontRef>
-        </p:style>
-        <p:txBody>
-          <a:bodyPr rtlCol="0" anchor="ctr"/>
-          <a:lstStyle/>
-          <a:p>
-            <a:pPr algn="ctr"/>
-            <a:r>
-              <a:rPr lang="en-AU" dirty="0">
-                <a:solidFill>
-                  <a:schemeClr val="tx1"/>
-                </a:solidFill>
-              </a:rPr>
-              <a:t>Ref out</a:t>
-            </a:r>
-          </a:p>
-        </p:txBody>
-      </p:sp>
-      <p:sp>
-        <p:nvSpPr>
-          <p:cNvPr id="28" name="Rectangle 27">
-            <a:extLst>
-              <a:ext uri="{FF2B5EF4-FFF2-40B4-BE49-F238E27FC236}">
-                <a16:creationId xmlns:a16="http://schemas.microsoft.com/office/drawing/2014/main" id="{DCD2FE95-9681-1D5A-EB73-C4F9E92120C4}"/>
-              </a:ext>
-            </a:extLst>
-          </p:cNvPr>
-          <p:cNvSpPr/>
-          <p:nvPr/>
-        </p:nvSpPr>
-        <p:spPr>
-          <a:xfrm>
-            <a:off x="8823006" y="1895373"/>
-            <a:ext cx="1403544" cy="724831"/>
-          </a:xfrm>
-          <a:prstGeom prst="rect">
-            <a:avLst/>
-          </a:prstGeom>
-          <a:solidFill>
-            <a:srgbClr val="CCCCCC"/>
-          </a:solidFill>
-          <a:ln>
-            <a:noFill/>
-          </a:ln>
-        </p:spPr>
-        <p:style>
-          <a:lnRef idx="2">
-            <a:schemeClr val="accent1">
-              <a:shade val="15000"/>
-            </a:schemeClr>
-          </a:lnRef>
-          <a:fillRef idx="1">
-            <a:schemeClr val="accent1"/>
-          </a:fillRef>
-          <a:effectRef idx="0">
-            <a:schemeClr val="accent1"/>
-          </a:effectRef>
-          <a:fontRef idx="minor">
-            <a:schemeClr val="lt1"/>
-          </a:fontRef>
-        </p:style>
-        <p:txBody>
-          <a:bodyPr rtlCol="0" anchor="ctr"/>
-          <a:lstStyle/>
-          <a:p>
-            <a:pPr algn="ctr"/>
-            <a:r>
-              <a:rPr lang="en-AU" dirty="0">
-                <a:solidFill>
-                  <a:schemeClr val="tx1"/>
-                </a:solidFill>
-              </a:rPr>
-              <a:t>Lock-in amplifier</a:t>
-            </a:r>
-          </a:p>
-        </p:txBody>
-      </p:sp>
-      <p:sp>
-        <p:nvSpPr>
-          <p:cNvPr id="29" name="Rectangle 28">
-            <a:extLst>
-              <a:ext uri="{FF2B5EF4-FFF2-40B4-BE49-F238E27FC236}">
-                <a16:creationId xmlns:a16="http://schemas.microsoft.com/office/drawing/2014/main" id="{8DE41CB9-A5EC-B57C-19F9-5E391EA0776F}"/>
-              </a:ext>
-            </a:extLst>
-          </p:cNvPr>
-          <p:cNvSpPr/>
-          <p:nvPr/>
-        </p:nvSpPr>
-        <p:spPr>
-          <a:xfrm>
-            <a:off x="9822670" y="1584791"/>
-            <a:ext cx="548551" cy="304951"/>
-          </a:xfrm>
-          <a:prstGeom prst="rect">
-            <a:avLst/>
-          </a:prstGeom>
-          <a:solidFill>
-            <a:srgbClr val="CCCCCC"/>
-          </a:solidFill>
-          <a:ln>
-            <a:noFill/>
-          </a:ln>
-        </p:spPr>
-        <p:style>
-          <a:lnRef idx="2">
-            <a:schemeClr val="accent1">
-              <a:shade val="15000"/>
-            </a:schemeClr>
-          </a:lnRef>
-          <a:fillRef idx="1">
-            <a:schemeClr val="accent1"/>
-          </a:fillRef>
-          <a:effectRef idx="0">
-            <a:schemeClr val="accent1"/>
-          </a:effectRef>
-          <a:fontRef idx="minor">
-            <a:schemeClr val="lt1"/>
-          </a:fontRef>
-        </p:style>
-        <p:txBody>
-          <a:bodyPr rtlCol="0" anchor="ctr"/>
-          <a:lstStyle/>
-          <a:p>
-            <a:pPr algn="ctr"/>
-            <a:r>
-              <a:rPr lang="en-AU" dirty="0">
-                <a:solidFill>
-                  <a:schemeClr val="tx1"/>
-                </a:solidFill>
-              </a:rPr>
-              <a:t>Out</a:t>
-            </a:r>
-          </a:p>
-        </p:txBody>
-      </p:sp>
-      <p:sp>
-        <p:nvSpPr>
-          <p:cNvPr id="30" name="Rectangle 29">
-            <a:extLst>
-              <a:ext uri="{FF2B5EF4-FFF2-40B4-BE49-F238E27FC236}">
-                <a16:creationId xmlns:a16="http://schemas.microsoft.com/office/drawing/2014/main" id="{4429B36A-D763-43B5-8AE2-53A933F66CFD}"/>
-              </a:ext>
-            </a:extLst>
-          </p:cNvPr>
-          <p:cNvSpPr/>
-          <p:nvPr/>
-        </p:nvSpPr>
-        <p:spPr>
-          <a:xfrm>
-            <a:off x="4538438" y="3301935"/>
-            <a:ext cx="948266" cy="254129"/>
-          </a:xfrm>
-          <a:prstGeom prst="rect">
-            <a:avLst/>
-          </a:prstGeom>
-          <a:solidFill>
-            <a:schemeClr val="bg1"/>
-          </a:solidFill>
-          <a:ln>
-            <a:noFill/>
-          </a:ln>
-        </p:spPr>
-        <p:style>
-          <a:lnRef idx="2">
-            <a:schemeClr val="accent1">
-              <a:shade val="15000"/>
-            </a:schemeClr>
-          </a:lnRef>
-          <a:fillRef idx="1">
-            <a:schemeClr val="accent1"/>
-          </a:fillRef>
-          <a:effectRef idx="0">
-            <a:schemeClr val="accent1"/>
-          </a:effectRef>
-          <a:fontRef idx="minor">
-            <a:schemeClr val="lt1"/>
-          </a:fontRef>
-        </p:style>
-        <p:txBody>
-          <a:bodyPr rtlCol="0" anchor="ctr"/>
-          <a:lstStyle/>
-          <a:p>
-            <a:pPr algn="ctr"/>
-            <a:r>
-              <a:rPr lang="en-AU" dirty="0">
-                <a:solidFill>
-                  <a:srgbClr val="0666CC"/>
-                </a:solidFill>
-              </a:rPr>
-              <a:t>Sample</a:t>
-            </a:r>
-          </a:p>
-        </p:txBody>
-      </p:sp>
-      <p:sp>
-        <p:nvSpPr>
-          <p:cNvPr id="31" name="Rectangle 30">
-            <a:extLst>
-              <a:ext uri="{FF2B5EF4-FFF2-40B4-BE49-F238E27FC236}">
-                <a16:creationId xmlns:a16="http://schemas.microsoft.com/office/drawing/2014/main" id="{C613C86F-1AA2-39C2-7C62-57578BC9A124}"/>
-              </a:ext>
-            </a:extLst>
-          </p:cNvPr>
-          <p:cNvSpPr/>
-          <p:nvPr/>
-        </p:nvSpPr>
-        <p:spPr>
-          <a:xfrm>
-            <a:off x="7002238" y="693251"/>
-            <a:ext cx="1125762" cy="724831"/>
-          </a:xfrm>
-          <a:prstGeom prst="rect">
-            <a:avLst/>
-          </a:prstGeom>
-          <a:solidFill>
-            <a:srgbClr val="CCCCCC"/>
-          </a:solidFill>
-          <a:ln>
-            <a:noFill/>
-          </a:ln>
-        </p:spPr>
-        <p:style>
-          <a:lnRef idx="2">
-            <a:schemeClr val="accent1">
-              <a:shade val="15000"/>
-            </a:schemeClr>
-          </a:lnRef>
-          <a:fillRef idx="1">
-            <a:schemeClr val="accent1"/>
-          </a:fillRef>
-          <a:effectRef idx="0">
-            <a:schemeClr val="accent1"/>
-          </a:effectRef>
-          <a:fontRef idx="minor">
-            <a:schemeClr val="lt1"/>
-          </a:fontRef>
-        </p:style>
-        <p:txBody>
-          <a:bodyPr rtlCol="0" anchor="ctr"/>
-          <a:lstStyle/>
-          <a:p>
-            <a:pPr algn="ctr"/>
-            <a:r>
-              <a:rPr lang="en-AU" dirty="0">
-                <a:solidFill>
-                  <a:schemeClr val="tx1"/>
-                </a:solidFill>
-              </a:rPr>
-              <a:t>Gauss Meter</a:t>
-            </a:r>
-          </a:p>
-        </p:txBody>
-      </p:sp>
-      <p:sp>
-        <p:nvSpPr>
-          <p:cNvPr id="32" name="Rectangle 31">
-            <a:extLst>
-              <a:ext uri="{FF2B5EF4-FFF2-40B4-BE49-F238E27FC236}">
-                <a16:creationId xmlns:a16="http://schemas.microsoft.com/office/drawing/2014/main" id="{485C7E9D-9380-8EAF-6E4A-A68C13F286A8}"/>
-              </a:ext>
-            </a:extLst>
-          </p:cNvPr>
-          <p:cNvSpPr/>
-          <p:nvPr/>
-        </p:nvSpPr>
-        <p:spPr>
-          <a:xfrm>
-            <a:off x="9050726" y="421471"/>
-            <a:ext cx="1320495" cy="724831"/>
-          </a:xfrm>
-          <a:prstGeom prst="rect">
-            <a:avLst/>
-          </a:prstGeom>
-          <a:solidFill>
-            <a:schemeClr val="bg1"/>
-          </a:solidFill>
-          <a:ln>
-            <a:noFill/>
-          </a:ln>
-        </p:spPr>
-        <p:style>
-          <a:lnRef idx="2">
-            <a:schemeClr val="accent1">
-              <a:shade val="15000"/>
-            </a:schemeClr>
-          </a:lnRef>
-          <a:fillRef idx="1">
-            <a:schemeClr val="accent1"/>
-          </a:fillRef>
-          <a:effectRef idx="0">
-            <a:schemeClr val="accent1"/>
-          </a:effectRef>
-          <a:fontRef idx="minor">
-            <a:schemeClr val="lt1"/>
-          </a:fontRef>
-        </p:style>
-        <p:txBody>
-          <a:bodyPr rtlCol="0" anchor="ctr"/>
-          <a:lstStyle/>
-          <a:p>
-            <a:pPr algn="ctr"/>
-            <a:r>
-              <a:rPr lang="en-AU" dirty="0">
-                <a:solidFill>
-                  <a:schemeClr val="tx1"/>
-                </a:solidFill>
-              </a:rPr>
-              <a:t>Schottky diode</a:t>
-            </a:r>
+            <a:endParaRPr lang="en-AU" dirty="0"/>
           </a:p>
         </p:txBody>
       </p:sp>

</xml_diff>